<commit_message>
📊 update data 2026-03-31 08:40
</commit_message>
<xml_diff>
--- a/presentation_migration_classexpert_schoolart.pptx
+++ b/presentation_migration_classexpert_schoolart.pptx
@@ -4,6 +4,9 @@
   <p:sldMasterIdLst>
     <p:sldMasterId id="2147483648" r:id="rId1"/>
   </p:sldMasterIdLst>
+  <p:notesMasterIdLst>
+    <p:notesMasterId r:id="rId11"/>
+  </p:notesMasterIdLst>
   <p:sldIdLst>
     <p:sldId id="256" r:id="rId2"/>
     <p:sldId id="257" r:id="rId3"/>
@@ -15,10 +18,7 @@
     <p:sldId id="263" r:id="rId9"/>
     <p:sldId id="264" r:id="rId10"/>
   </p:sldIdLst>
-  <p:notesMasterIdLst>
-    <p:notesMasterId r:id="rId11"/>
-  </p:notesMasterIdLst>
-  <p:sldSz cx="9144000" cy="5143500"/>
+  <p:sldSz cx="9144000" cy="5143500" type="screen16x9"/>
   <p:notesSz cx="5143500" cy="9144000"/>
   <p:defaultTextStyle>
     <a:lvl1pPr marL="0" algn="l" defTabSz="914400" rtl="0" eaLnBrk="1" latinLnBrk="0" hangingPunct="1">
@@ -112,6 +112,11 @@
       </a:defRPr>
     </a:lvl9pPr>
   </p:defaultTextStyle>
+  <p:extLst>
+    <p:ext uri="{EFAFB233-063F-42B5-8137-9DF3F51BA10A}">
+      <p15:sldGuideLst xmlns:p15="http://schemas.microsoft.com/office/powerpoint/2012/main"/>
+    </p:ext>
+  </p:extLst>
 </p:presentation>
 </file>
 
@@ -137,234 +142,10 @@
           <a:chExt cx="0" cy="0"/>
         </a:xfrm>
       </p:grpSpPr>
-      <p:sp>
-        <p:nvSpPr>
-          <p:cNvPr id="2" name="Header Placeholder 1"/>
-          <p:cNvSpPr>
-            <a:spLocks noGrp="1"/>
-          </p:cNvSpPr>
-          <p:nvPr>
-            <p:ph type="hdr" sz="quarter"/>
-          </p:nvPr>
-        </p:nvSpPr>
-        <p:spPr>
-          <a:xfrm>
-            <a:off x="0" y="0"/>
-            <a:ext cx="2971800" cy="458788"/>
-          </a:xfrm>
-          <a:prstGeom prst="rect">
-            <a:avLst/>
-          </a:prstGeom>
-        </p:spPr>
-        <p:txBody>
-          <a:bodyPr vert="horz" lIns="91440" tIns="45720" rIns="91440" bIns="45720" rtlCol="0"/>
-          <a:lstStyle>
-            <a:lvl1pPr algn="l">
-              <a:defRPr sz="1200"/>
-            </a:lvl1pPr>
-          </a:lstStyle>
-          <a:p>
-            <a:endParaRPr lang="en-US"/>
-          </a:p>
-        </p:txBody>
-      </p:sp>
-      <p:sp>
-        <p:nvSpPr>
-          <p:cNvPr id="3" name="Date Placeholder 2"/>
-          <p:cNvSpPr>
-            <a:spLocks noGrp="1"/>
-          </p:cNvSpPr>
-          <p:nvPr>
-            <p:ph type="dt" idx="1"/>
-          </p:nvPr>
-        </p:nvSpPr>
-        <p:spPr>
-          <a:xfrm>
-            <a:off x="3884613" y="0"/>
-            <a:ext cx="2971800" cy="458788"/>
-          </a:xfrm>
-          <a:prstGeom prst="rect">
-            <a:avLst/>
-          </a:prstGeom>
-        </p:spPr>
-        <p:txBody>
-          <a:bodyPr vert="horz" lIns="91440" tIns="45720" rIns="91440" bIns="45720" rtlCol="0"/>
-          <a:lstStyle>
-            <a:lvl1pPr algn="r">
-              <a:defRPr sz="1200"/>
-            </a:lvl1pPr>
-          </a:lstStyle>
-          <a:p>
-            <a:fld id="{5282F153-3F37-0F45-9E97-73ACFA13230C}" type="datetimeFigureOut">
-              <a:rPr lang="en-US"/>
-              <a:t>7/23/19</a:t>
-            </a:fld>
-            <a:endParaRPr lang="en-US"/>
-          </a:p>
-        </p:txBody>
-      </p:sp>
-      <p:sp>
-        <p:nvSpPr>
-          <p:cNvPr id="4" name="Slide Image Placeholder 3"/>
-          <p:cNvSpPr>
-            <a:spLocks noGrp="1" noRot="1" noChangeAspect="1"/>
-          </p:cNvSpPr>
-          <p:nvPr>
-            <p:ph type="sldImg" idx="2"/>
-          </p:nvPr>
-        </p:nvSpPr>
-        <p:spPr>
-          <a:xfrm>
-            <a:off x="685800" y="1143000"/>
-            <a:ext cx="5486400" cy="3086100"/>
-          </a:xfrm>
-          <a:prstGeom prst="rect">
-            <a:avLst/>
-          </a:prstGeom>
-          <a:noFill/>
-          <a:ln w="12700">
-            <a:solidFill>
-              <a:prstClr val="black"/>
-            </a:solidFill>
-          </a:ln>
-        </p:spPr>
-        <p:txBody>
-          <a:bodyPr vert="horz" lIns="91440" tIns="45720" rIns="91440" bIns="45720" rtlCol="0" anchor="ctr"/>
-          <a:lstStyle/>
-          <a:p>
-            <a:endParaRPr lang="en-US"/>
-          </a:p>
-        </p:txBody>
-      </p:sp>
-      <p:sp>
-        <p:nvSpPr>
-          <p:cNvPr id="5" name="Notes Placeholder 4"/>
-          <p:cNvSpPr>
-            <a:spLocks noGrp="1"/>
-          </p:cNvSpPr>
-          <p:nvPr>
-            <p:ph type="body" sz="quarter" idx="3"/>
-          </p:nvPr>
-        </p:nvSpPr>
-        <p:spPr>
-          <a:xfrm>
-            <a:off x="685800" y="4400550"/>
-            <a:ext cx="5486400" cy="3600450"/>
-          </a:xfrm>
-          <a:prstGeom prst="rect">
-            <a:avLst/>
-          </a:prstGeom>
-        </p:spPr>
-        <p:txBody>
-          <a:bodyPr vert="horz" lIns="91440" tIns="45720" rIns="91440" bIns="45720" rtlCol="0"/>
-          <a:lstStyle/>
-          <a:p>
-            <a:pPr lvl="0"/>
-            <a:r>
-              <a:rPr lang="en-US"/>
-              <a:t>Click to edit Master text styles</a:t>
-            </a:r>
-          </a:p>
-          <a:p>
-            <a:pPr lvl="1"/>
-            <a:r>
-              <a:rPr lang="en-US"/>
-              <a:t>Second level</a:t>
-            </a:r>
-          </a:p>
-          <a:p>
-            <a:pPr lvl="2"/>
-            <a:r>
-              <a:rPr lang="en-US"/>
-              <a:t>Third level</a:t>
-            </a:r>
-          </a:p>
-          <a:p>
-            <a:pPr lvl="3"/>
-            <a:r>
-              <a:rPr lang="en-US"/>
-              <a:t>Fourth level</a:t>
-            </a:r>
-          </a:p>
-          <a:p>
-            <a:pPr lvl="4"/>
-            <a:r>
-              <a:rPr lang="en-US"/>
-              <a:t>Fifth level</a:t>
-            </a:r>
-          </a:p>
-        </p:txBody>
-      </p:sp>
-      <p:sp>
-        <p:nvSpPr>
-          <p:cNvPr id="6" name="Footer Placeholder 5"/>
-          <p:cNvSpPr>
-            <a:spLocks noGrp="1"/>
-          </p:cNvSpPr>
-          <p:nvPr>
-            <p:ph type="ftr" sz="quarter" idx="4"/>
-          </p:nvPr>
-        </p:nvSpPr>
-        <p:spPr>
-          <a:xfrm>
-            <a:off x="0" y="8685213"/>
-            <a:ext cx="2971800" cy="458787"/>
-          </a:xfrm>
-          <a:prstGeom prst="rect">
-            <a:avLst/>
-          </a:prstGeom>
-        </p:spPr>
-        <p:txBody>
-          <a:bodyPr vert="horz" lIns="91440" tIns="45720" rIns="91440" bIns="45720" rtlCol="0" anchor="b"/>
-          <a:lstStyle>
-            <a:lvl1pPr algn="l">
-              <a:defRPr sz="1200"/>
-            </a:lvl1pPr>
-          </a:lstStyle>
-          <a:p>
-            <a:endParaRPr lang="en-US"/>
-          </a:p>
-        </p:txBody>
-      </p:sp>
-      <p:sp>
-        <p:nvSpPr>
-          <p:cNvPr id="7" name="Slide Number Placeholder 6"/>
-          <p:cNvSpPr>
-            <a:spLocks noGrp="1"/>
-          </p:cNvSpPr>
-          <p:nvPr>
-            <p:ph type="sldNum" sz="quarter" idx="5"/>
-          </p:nvPr>
-        </p:nvSpPr>
-        <p:spPr>
-          <a:xfrm>
-            <a:off x="3884613" y="8685213"/>
-            <a:ext cx="2971800" cy="458787"/>
-          </a:xfrm>
-          <a:prstGeom prst="rect">
-            <a:avLst/>
-          </a:prstGeom>
-        </p:spPr>
-        <p:txBody>
-          <a:bodyPr vert="horz" lIns="91440" tIns="45720" rIns="91440" bIns="45720" rtlCol="0" anchor="b"/>
-          <a:lstStyle>
-            <a:lvl1pPr algn="r">
-              <a:defRPr sz="1200"/>
-            </a:lvl1pPr>
-          </a:lstStyle>
-          <a:p>
-            <a:fld id="{CE5E9CC1-C706-0F49-92D6-E571CC5EEA8F}" type="slidenum">
-              <a:rPr lang="en-US"/>
-              <a:t>‹#›</a:t>
-            </a:fld>
-            <a:endParaRPr lang="en-US"/>
-          </a:p>
-        </p:txBody>
-      </p:sp>
     </p:spTree>
     <p:extLst>
       <p:ext uri="{BB962C8B-B14F-4D97-AF65-F5344CB8AC3E}">
-        <p14:creationId xmlns:p14="http://schemas.microsoft.com/office/powerpoint/2010/main" val="1024086991"/>
+        <p14:creationId xmlns:p14="http://schemas.microsoft.com/office/powerpoint/2010/main" val="117552705"/>
       </p:ext>
     </p:extLst>
   </p:cSld>
@@ -508,10 +289,6 @@
           <a:bodyPr/>
           <a:lstStyle/>
           <a:p>
-            <a:r>
-              <a:rPr lang="en-US" dirty="0"/>
-              <a:t/>
-            </a:r>
             <a:endParaRPr lang="en-US" dirty="0"/>
           </a:p>
         </p:txBody>
@@ -596,10 +373,6 @@
           <a:bodyPr/>
           <a:lstStyle/>
           <a:p>
-            <a:r>
-              <a:rPr lang="en-US" dirty="0"/>
-              <a:t/>
-            </a:r>
             <a:endParaRPr lang="en-US" dirty="0"/>
           </a:p>
         </p:txBody>
@@ -684,10 +457,6 @@
           <a:bodyPr/>
           <a:lstStyle/>
           <a:p>
-            <a:r>
-              <a:rPr lang="en-US" dirty="0"/>
-              <a:t/>
-            </a:r>
             <a:endParaRPr lang="en-US" dirty="0"/>
           </a:p>
         </p:txBody>
@@ -772,10 +541,6 @@
           <a:bodyPr/>
           <a:lstStyle/>
           <a:p>
-            <a:r>
-              <a:rPr lang="en-US" dirty="0"/>
-              <a:t/>
-            </a:r>
             <a:endParaRPr lang="en-US" dirty="0"/>
           </a:p>
         </p:txBody>
@@ -860,10 +625,6 @@
           <a:bodyPr/>
           <a:lstStyle/>
           <a:p>
-            <a:r>
-              <a:rPr lang="en-US" dirty="0"/>
-              <a:t/>
-            </a:r>
             <a:endParaRPr lang="en-US" dirty="0"/>
           </a:p>
         </p:txBody>
@@ -948,10 +709,6 @@
           <a:bodyPr/>
           <a:lstStyle/>
           <a:p>
-            <a:r>
-              <a:rPr lang="en-US" dirty="0"/>
-              <a:t/>
-            </a:r>
             <a:endParaRPr lang="en-US" dirty="0"/>
           </a:p>
         </p:txBody>
@@ -1036,10 +793,6 @@
           <a:bodyPr/>
           <a:lstStyle/>
           <a:p>
-            <a:r>
-              <a:rPr lang="en-US" dirty="0"/>
-              <a:t/>
-            </a:r>
             <a:endParaRPr lang="en-US" dirty="0"/>
           </a:p>
         </p:txBody>
@@ -1124,10 +877,6 @@
           <a:bodyPr/>
           <a:lstStyle/>
           <a:p>
-            <a:r>
-              <a:rPr lang="en-US" dirty="0"/>
-              <a:t/>
-            </a:r>
             <a:endParaRPr lang="en-US" dirty="0"/>
           </a:p>
         </p:txBody>
@@ -1212,10 +961,6 @@
           <a:bodyPr/>
           <a:lstStyle/>
           <a:p>
-            <a:r>
-              <a:rPr lang="en-US" dirty="0"/>
-              <a:t/>
-            </a:r>
             <a:endParaRPr lang="en-US" dirty="0"/>
           </a:p>
         </p:txBody>
@@ -1289,6 +1034,11 @@
 <file path=ppt/slideMasters/slideMaster1.xml><?xml version="1.0" encoding="utf-8"?>
 <p:sldMaster xmlns:a="http://schemas.openxmlformats.org/drawingml/2006/main" xmlns:r="http://schemas.openxmlformats.org/officeDocument/2006/relationships" xmlns:p="http://schemas.openxmlformats.org/presentationml/2006/main">
   <p:cSld>
+    <p:bg>
+      <p:bgRef idx="1001">
+        <a:schemeClr val="bg1"/>
+      </p:bgRef>
+    </p:bg>
     <p:spTree>
       <p:nvGrpSpPr>
         <p:cNvPr id="1" name=""/>
@@ -1571,6 +1321,7 @@
         <a:solidFill>
           <a:srgbClr val="1A1A2E"/>
         </a:solidFill>
+        <a:effectLst/>
       </p:bgPr>
     </p:bg>
     <p:spTree>
@@ -1608,11 +1359,11 @@
           <a:bodyPr wrap="square" rtlCol="0" anchor="ctr"/>
           <a:lstStyle/>
           <a:p>
-            <a:pPr indent="0" marL="0">
+            <a:pPr marL="0" indent="0">
               <a:buNone/>
             </a:pPr>
             <a:r>
-              <a:rPr lang="en-US" sz="4800" b="1" spc="600" kern="0" dirty="0">
+              <a:rPr lang="en-US" sz="4800" b="1" kern="0" spc="600" dirty="0">
                 <a:solidFill>
                   <a:srgbClr val="FFFFFF"/>
                 </a:solidFill>
@@ -1647,7 +1398,7 @@
           <a:bodyPr wrap="square" rtlCol="0" anchor="ctr"/>
           <a:lstStyle/>
           <a:p>
-            <a:pPr indent="0" marL="0">
+            <a:pPr marL="0" indent="0">
               <a:buNone/>
             </a:pPr>
             <a:r>
@@ -1706,7 +1457,7 @@
           <a:bodyPr wrap="square" rtlCol="0" anchor="ctr"/>
           <a:lstStyle/>
           <a:p>
-            <a:pPr indent="0" marL="0">
+            <a:pPr marL="0" indent="0">
               <a:buNone/>
             </a:pPr>
             <a:r>
@@ -1745,7 +1496,7 @@
           <a:bodyPr wrap="square" rtlCol="0" anchor="ctr"/>
           <a:lstStyle/>
           <a:p>
-            <a:pPr indent="0" marL="0">
+            <a:pPr marL="0" indent="0">
               <a:buNone/>
             </a:pPr>
             <a:r>
@@ -1779,6 +1530,7 @@
         <a:solidFill>
           <a:srgbClr val="FFFFFF"/>
         </a:solidFill>
+        <a:effectLst/>
       </p:bgPr>
     </p:bg>
     <p:spTree>
@@ -1816,7 +1568,7 @@
           <a:bodyPr wrap="square" lIns="0" tIns="0" rIns="0" bIns="0" rtlCol="0" anchor="ctr"/>
           <a:lstStyle/>
           <a:p>
-            <a:pPr indent="0" marL="0">
+            <a:pPr marL="0" indent="0">
               <a:buNone/>
             </a:pPr>
             <a:r>
@@ -1873,7 +1625,7 @@
           </a:solidFill>
           <a:ln/>
           <a:effectLst>
-            <a:outerShdw sx="100000" sy="100000" kx="0" ky="0" algn="bl" rotWithShape="0" blurRad="76200" dist="25400" dir="8100000">
+            <a:outerShdw blurRad="76200" dist="25400" dir="8100000" algn="bl" rotWithShape="0">
               <a:srgbClr val="000000">
                 <a:alpha val="12000"/>
               </a:srgbClr>
@@ -1902,7 +1654,7 @@
           <a:bodyPr wrap="square" rtlCol="0" anchor="ctr"/>
           <a:lstStyle/>
           <a:p>
-            <a:pPr algn="ctr" indent="0" marL="0">
+            <a:pPr marL="0" indent="0" algn="ctr">
               <a:buNone/>
             </a:pPr>
             <a:r>
@@ -1941,7 +1693,7 @@
           <a:bodyPr wrap="square" rtlCol="0" anchor="ctr"/>
           <a:lstStyle/>
           <a:p>
-            <a:pPr algn="ctr" indent="0" marL="0">
+            <a:pPr marL="0" indent="0" algn="ctr">
               <a:buNone/>
             </a:pPr>
             <a:r>
@@ -1980,7 +1732,7 @@
           <a:bodyPr wrap="square" rtlCol="0" anchor="ctr"/>
           <a:lstStyle/>
           <a:p>
-            <a:pPr algn="ctr" indent="0" marL="0">
+            <a:pPr marL="0" indent="0" algn="ctr">
               <a:buNone/>
             </a:pPr>
             <a:r>
@@ -2017,7 +1769,7 @@
           </a:solidFill>
           <a:ln/>
           <a:effectLst>
-            <a:outerShdw sx="100000" sy="100000" kx="0" ky="0" algn="bl" rotWithShape="0" blurRad="76200" dist="25400" dir="8100000">
+            <a:outerShdw blurRad="76200" dist="25400" dir="8100000" algn="bl" rotWithShape="0">
               <a:srgbClr val="000000">
                 <a:alpha val="12000"/>
               </a:srgbClr>
@@ -2046,7 +1798,7 @@
           <a:bodyPr wrap="square" rtlCol="0" anchor="ctr"/>
           <a:lstStyle/>
           <a:p>
-            <a:pPr algn="ctr" indent="0" marL="0">
+            <a:pPr marL="0" indent="0" algn="ctr">
               <a:buNone/>
             </a:pPr>
             <a:r>
@@ -2085,7 +1837,7 @@
           <a:bodyPr wrap="square" rtlCol="0" anchor="ctr"/>
           <a:lstStyle/>
           <a:p>
-            <a:pPr algn="ctr" indent="0" marL="0">
+            <a:pPr marL="0" indent="0" algn="ctr">
               <a:buNone/>
             </a:pPr>
             <a:r>
@@ -2124,7 +1876,7 @@
           <a:bodyPr wrap="square" rtlCol="0" anchor="ctr"/>
           <a:lstStyle/>
           <a:p>
-            <a:pPr algn="ctr" indent="0" marL="0">
+            <a:pPr marL="0" indent="0" algn="ctr">
               <a:buNone/>
             </a:pPr>
             <a:r>
@@ -2161,7 +1913,7 @@
           </a:solidFill>
           <a:ln/>
           <a:effectLst>
-            <a:outerShdw sx="100000" sy="100000" kx="0" ky="0" algn="bl" rotWithShape="0" blurRad="76200" dist="25400" dir="8100000">
+            <a:outerShdw blurRad="76200" dist="25400" dir="8100000" algn="bl" rotWithShape="0">
               <a:srgbClr val="000000">
                 <a:alpha val="12000"/>
               </a:srgbClr>
@@ -2190,7 +1942,7 @@
           <a:bodyPr wrap="square" rtlCol="0" anchor="ctr"/>
           <a:lstStyle/>
           <a:p>
-            <a:pPr algn="ctr" indent="0" marL="0">
+            <a:pPr marL="0" indent="0" algn="ctr">
               <a:buNone/>
             </a:pPr>
             <a:r>
@@ -2229,7 +1981,7 @@
           <a:bodyPr wrap="square" rtlCol="0" anchor="ctr"/>
           <a:lstStyle/>
           <a:p>
-            <a:pPr algn="ctr" indent="0" marL="0">
+            <a:pPr marL="0" indent="0" algn="ctr">
               <a:buNone/>
             </a:pPr>
             <a:r>
@@ -2268,7 +2020,7 @@
           <a:bodyPr wrap="square" rtlCol="0" anchor="ctr"/>
           <a:lstStyle/>
           <a:p>
-            <a:pPr algn="ctr" indent="0" marL="0">
+            <a:pPr marL="0" indent="0" algn="ctr">
               <a:buNone/>
             </a:pPr>
             <a:r>
@@ -2305,7 +2057,7 @@
           </a:solidFill>
           <a:ln/>
           <a:effectLst>
-            <a:outerShdw sx="100000" sy="100000" kx="0" ky="0" algn="bl" rotWithShape="0" blurRad="76200" dist="25400" dir="8100000">
+            <a:outerShdw blurRad="76200" dist="25400" dir="8100000" algn="bl" rotWithShape="0">
               <a:srgbClr val="000000">
                 <a:alpha val="12000"/>
               </a:srgbClr>
@@ -2334,7 +2086,7 @@
           <a:bodyPr wrap="square" rtlCol="0" anchor="ctr"/>
           <a:lstStyle/>
           <a:p>
-            <a:pPr algn="ctr" indent="0" marL="0">
+            <a:pPr marL="0" indent="0" algn="ctr">
               <a:buNone/>
             </a:pPr>
             <a:r>
@@ -2373,7 +2125,7 @@
           <a:bodyPr wrap="square" rtlCol="0" anchor="ctr"/>
           <a:lstStyle/>
           <a:p>
-            <a:pPr algn="ctr" indent="0" marL="0">
+            <a:pPr marL="0" indent="0" algn="ctr">
               <a:buNone/>
             </a:pPr>
             <a:r>
@@ -2412,7 +2164,7 @@
           <a:bodyPr wrap="square" rtlCol="0" anchor="ctr"/>
           <a:lstStyle/>
           <a:p>
-            <a:pPr algn="ctr" indent="0" marL="0">
+            <a:pPr marL="0" indent="0" algn="ctr">
               <a:buNone/>
             </a:pPr>
             <a:r>
@@ -2449,7 +2201,7 @@
           </a:solidFill>
           <a:ln/>
           <a:effectLst>
-            <a:outerShdw sx="100000" sy="100000" kx="0" ky="0" algn="bl" rotWithShape="0" blurRad="76200" dist="25400" dir="8100000">
+            <a:outerShdw blurRad="76200" dist="25400" dir="8100000" algn="bl" rotWithShape="0">
               <a:srgbClr val="000000">
                 <a:alpha val="12000"/>
               </a:srgbClr>
@@ -2478,7 +2230,7 @@
           <a:bodyPr wrap="square" rtlCol="0" anchor="ctr"/>
           <a:lstStyle/>
           <a:p>
-            <a:pPr algn="ctr" indent="0" marL="0">
+            <a:pPr marL="0" indent="0" algn="ctr">
               <a:buNone/>
             </a:pPr>
             <a:r>
@@ -2517,7 +2269,7 @@
           <a:bodyPr wrap="square" rtlCol="0" anchor="ctr"/>
           <a:lstStyle/>
           <a:p>
-            <a:pPr algn="ctr" indent="0" marL="0">
+            <a:pPr marL="0" indent="0" algn="ctr">
               <a:buNone/>
             </a:pPr>
             <a:r>
@@ -2556,7 +2308,7 @@
           <a:bodyPr wrap="square" rtlCol="0" anchor="ctr"/>
           <a:lstStyle/>
           <a:p>
-            <a:pPr algn="ctr" indent="0" marL="0">
+            <a:pPr marL="0" indent="0" algn="ctr">
               <a:buNone/>
             </a:pPr>
             <a:r>
@@ -2593,7 +2345,7 @@
           </a:solidFill>
           <a:ln/>
           <a:effectLst>
-            <a:outerShdw sx="100000" sy="100000" kx="0" ky="0" algn="bl" rotWithShape="0" blurRad="76200" dist="25400" dir="8100000">
+            <a:outerShdw blurRad="76200" dist="25400" dir="8100000" algn="bl" rotWithShape="0">
               <a:srgbClr val="000000">
                 <a:alpha val="12000"/>
               </a:srgbClr>
@@ -2622,7 +2374,7 @@
           <a:bodyPr wrap="square" rtlCol="0" anchor="ctr"/>
           <a:lstStyle/>
           <a:p>
-            <a:pPr algn="ctr" indent="0" marL="0">
+            <a:pPr marL="0" indent="0" algn="ctr">
               <a:buNone/>
             </a:pPr>
             <a:r>
@@ -2661,7 +2413,7 @@
           <a:bodyPr wrap="square" rtlCol="0" anchor="ctr"/>
           <a:lstStyle/>
           <a:p>
-            <a:pPr algn="ctr" indent="0" marL="0">
+            <a:pPr marL="0" indent="0" algn="ctr">
               <a:buNone/>
             </a:pPr>
             <a:r>
@@ -2700,7 +2452,7 @@
           <a:bodyPr wrap="square" rtlCol="0" anchor="ctr"/>
           <a:lstStyle/>
           <a:p>
-            <a:pPr algn="ctr" indent="0" marL="0">
+            <a:pPr marL="0" indent="0" algn="ctr">
               <a:buNone/>
             </a:pPr>
             <a:r>
@@ -2737,7 +2489,7 @@
           </a:solidFill>
           <a:ln/>
           <a:effectLst>
-            <a:outerShdw sx="100000" sy="100000" kx="0" ky="0" algn="bl" rotWithShape="0" blurRad="76200" dist="25400" dir="8100000">
+            <a:outerShdw blurRad="76200" dist="25400" dir="8100000" algn="bl" rotWithShape="0">
               <a:srgbClr val="000000">
                 <a:alpha val="12000"/>
               </a:srgbClr>
@@ -2766,7 +2518,7 @@
           <a:bodyPr wrap="square" rtlCol="0" anchor="ctr"/>
           <a:lstStyle/>
           <a:p>
-            <a:pPr algn="ctr" indent="0" marL="0">
+            <a:pPr marL="0" indent="0" algn="ctr">
               <a:buNone/>
             </a:pPr>
             <a:r>
@@ -2805,7 +2557,7 @@
           <a:bodyPr wrap="square" rtlCol="0" anchor="ctr"/>
           <a:lstStyle/>
           <a:p>
-            <a:pPr algn="ctr" indent="0" marL="0">
+            <a:pPr marL="0" indent="0" algn="ctr">
               <a:buNone/>
             </a:pPr>
             <a:r>
@@ -2844,7 +2596,7 @@
           <a:bodyPr wrap="square" rtlCol="0" anchor="ctr"/>
           <a:lstStyle/>
           <a:p>
-            <a:pPr algn="ctr" indent="0" marL="0">
+            <a:pPr marL="0" indent="0" algn="ctr">
               <a:buNone/>
             </a:pPr>
             <a:r>
@@ -2881,7 +2633,7 @@
           </a:solidFill>
           <a:ln/>
           <a:effectLst>
-            <a:outerShdw sx="100000" sy="100000" kx="0" ky="0" algn="bl" rotWithShape="0" blurRad="76200" dist="25400" dir="8100000">
+            <a:outerShdw blurRad="76200" dist="25400" dir="8100000" algn="bl" rotWithShape="0">
               <a:srgbClr val="000000">
                 <a:alpha val="12000"/>
               </a:srgbClr>
@@ -2910,7 +2662,7 @@
           <a:bodyPr wrap="square" rtlCol="0" anchor="ctr"/>
           <a:lstStyle/>
           <a:p>
-            <a:pPr algn="ctr" indent="0" marL="0">
+            <a:pPr marL="0" indent="0" algn="ctr">
               <a:buNone/>
             </a:pPr>
             <a:r>
@@ -2949,7 +2701,7 @@
           <a:bodyPr wrap="square" rtlCol="0" anchor="ctr"/>
           <a:lstStyle/>
           <a:p>
-            <a:pPr algn="ctr" indent="0" marL="0">
+            <a:pPr marL="0" indent="0" algn="ctr">
               <a:buNone/>
             </a:pPr>
             <a:r>
@@ -2988,7 +2740,7 @@
           <a:bodyPr wrap="square" rtlCol="0" anchor="ctr"/>
           <a:lstStyle/>
           <a:p>
-            <a:pPr algn="ctr" indent="0" marL="0">
+            <a:pPr marL="0" indent="0" algn="ctr">
               <a:buNone/>
             </a:pPr>
             <a:r>
@@ -3022,6 +2774,7 @@
         <a:solidFill>
           <a:srgbClr val="FFFFFF"/>
         </a:solidFill>
+        <a:effectLst/>
       </p:bgPr>
     </p:bg>
     <p:spTree>
@@ -3059,7 +2812,7 @@
           <a:bodyPr wrap="square" lIns="0" tIns="0" rIns="0" bIns="0" rtlCol="0" anchor="ctr"/>
           <a:lstStyle/>
           <a:p>
-            <a:pPr indent="0" marL="0">
+            <a:pPr marL="0" indent="0">
               <a:buNone/>
             </a:pPr>
             <a:r>
@@ -3113,19 +2866,55 @@
         </p:nvGraphicFramePr>
         <p:xfrm>
           <a:off x="457200" y="1005840"/>
-          <a:ext cx="8229600" cy="914400"/>
+          <a:ext cx="7315200" cy="1965960"/>
         </p:xfrm>
         <a:graphic>
           <a:graphicData uri="http://schemas.openxmlformats.org/drawingml/2006/table">
             <a:tbl>
               <a:tblPr/>
               <a:tblGrid>
-                <a:gridCol w="2286000"/>
-                <a:gridCol w="731520"/>
-                <a:gridCol w="822960"/>
-                <a:gridCol w="914400"/>
-                <a:gridCol w="1371600"/>
-                <a:gridCol w="1188720"/>
+                <a:gridCol w="2286000">
+                  <a:extLst>
+                    <a:ext uri="{9D8B030D-6E8A-4147-A177-3AD203B41FA5}">
+                      <a16:colId xmlns:a16="http://schemas.microsoft.com/office/drawing/2014/main" val="20000"/>
+                    </a:ext>
+                  </a:extLst>
+                </a:gridCol>
+                <a:gridCol w="731520">
+                  <a:extLst>
+                    <a:ext uri="{9D8B030D-6E8A-4147-A177-3AD203B41FA5}">
+                      <a16:colId xmlns:a16="http://schemas.microsoft.com/office/drawing/2014/main" val="20001"/>
+                    </a:ext>
+                  </a:extLst>
+                </a:gridCol>
+                <a:gridCol w="822960">
+                  <a:extLst>
+                    <a:ext uri="{9D8B030D-6E8A-4147-A177-3AD203B41FA5}">
+                      <a16:colId xmlns:a16="http://schemas.microsoft.com/office/drawing/2014/main" val="20002"/>
+                    </a:ext>
+                  </a:extLst>
+                </a:gridCol>
+                <a:gridCol w="914400">
+                  <a:extLst>
+                    <a:ext uri="{9D8B030D-6E8A-4147-A177-3AD203B41FA5}">
+                      <a16:colId xmlns:a16="http://schemas.microsoft.com/office/drawing/2014/main" val="20003"/>
+                    </a:ext>
+                  </a:extLst>
+                </a:gridCol>
+                <a:gridCol w="1371600">
+                  <a:extLst>
+                    <a:ext uri="{9D8B030D-6E8A-4147-A177-3AD203B41FA5}">
+                      <a16:colId xmlns:a16="http://schemas.microsoft.com/office/drawing/2014/main" val="20004"/>
+                    </a:ext>
+                  </a:extLst>
+                </a:gridCol>
+                <a:gridCol w="1188720">
+                  <a:extLst>
+                    <a:ext uri="{9D8B030D-6E8A-4147-A177-3AD203B41FA5}">
+                      <a16:colId xmlns:a16="http://schemas.microsoft.com/office/drawing/2014/main" val="20005"/>
+                    </a:ext>
+                  </a:extLst>
+                </a:gridCol>
               </a:tblGrid>
               <a:tr h="0">
                 <a:tc>
@@ -3133,7 +2922,7 @@
                     <a:bodyPr/>
                     <a:lstStyle/>
                     <a:p>
-                      <a:pPr indent="0" marL="0">
+                      <a:pPr marL="0" indent="0">
                         <a:buNone/>
                       </a:pPr>
                       <a:r>
@@ -3154,7 +2943,7 @@
                       </a:endParaRPr>
                     </a:p>
                   </a:txBody>
-                  <a:tcPr marL="91440" marR="91440" marT="45720" marB="45720">
+                  <a:tcPr>
                     <a:lnL w="6350" cap="flat" cmpd="sng" algn="ctr">
                       <a:solidFill>
                         <a:srgbClr val="E2E8F0"/>
@@ -3201,7 +2990,7 @@
                     <a:bodyPr/>
                     <a:lstStyle/>
                     <a:p>
-                      <a:pPr indent="0" marL="0">
+                      <a:pPr marL="0" indent="0">
                         <a:buNone/>
                       </a:pPr>
                       <a:r>
@@ -3222,7 +3011,7 @@
                       </a:endParaRPr>
                     </a:p>
                   </a:txBody>
-                  <a:tcPr marL="91440" marR="91440" marT="45720" marB="45720">
+                  <a:tcPr>
                     <a:lnL w="6350" cap="flat" cmpd="sng" algn="ctr">
                       <a:solidFill>
                         <a:srgbClr val="E2E8F0"/>
@@ -3269,7 +3058,7 @@
                     <a:bodyPr/>
                     <a:lstStyle/>
                     <a:p>
-                      <a:pPr indent="0" marL="0">
+                      <a:pPr marL="0" indent="0">
                         <a:buNone/>
                       </a:pPr>
                       <a:r>
@@ -3290,7 +3079,7 @@
                       </a:endParaRPr>
                     </a:p>
                   </a:txBody>
-                  <a:tcPr marL="91440" marR="91440" marT="45720" marB="45720">
+                  <a:tcPr>
                     <a:lnL w="6350" cap="flat" cmpd="sng" algn="ctr">
                       <a:solidFill>
                         <a:srgbClr val="E2E8F0"/>
@@ -3337,7 +3126,7 @@
                     <a:bodyPr/>
                     <a:lstStyle/>
                     <a:p>
-                      <a:pPr indent="0" marL="0">
+                      <a:pPr marL="0" indent="0">
                         <a:buNone/>
                       </a:pPr>
                       <a:r>
@@ -3358,7 +3147,7 @@
                       </a:endParaRPr>
                     </a:p>
                   </a:txBody>
-                  <a:tcPr marL="91440" marR="91440" marT="45720" marB="45720">
+                  <a:tcPr>
                     <a:lnL w="6350" cap="flat" cmpd="sng" algn="ctr">
                       <a:solidFill>
                         <a:srgbClr val="E2E8F0"/>
@@ -3405,7 +3194,7 @@
                     <a:bodyPr/>
                     <a:lstStyle/>
                     <a:p>
-                      <a:pPr indent="0" marL="0">
+                      <a:pPr marL="0" indent="0">
                         <a:buNone/>
                       </a:pPr>
                       <a:r>
@@ -3426,7 +3215,7 @@
                       </a:endParaRPr>
                     </a:p>
                   </a:txBody>
-                  <a:tcPr marL="91440" marR="91440" marT="45720" marB="45720">
+                  <a:tcPr>
                     <a:lnL w="6350" cap="flat" cmpd="sng" algn="ctr">
                       <a:solidFill>
                         <a:srgbClr val="E2E8F0"/>
@@ -3473,7 +3262,7 @@
                     <a:bodyPr/>
                     <a:lstStyle/>
                     <a:p>
-                      <a:pPr indent="0" marL="0">
+                      <a:pPr marL="0" indent="0">
                         <a:buNone/>
                       </a:pPr>
                       <a:r>
@@ -3494,7 +3283,7 @@
                       </a:endParaRPr>
                     </a:p>
                   </a:txBody>
-                  <a:tcPr marL="91440" marR="91440" marT="45720" marB="45720">
+                  <a:tcPr>
                     <a:lnL w="6350" cap="flat" cmpd="sng" algn="ctr">
                       <a:solidFill>
                         <a:srgbClr val="E2E8F0"/>
@@ -3536,6 +3325,11 @@
                     </a:solidFill>
                   </a:tcPr>
                 </a:tc>
+                <a:extLst>
+                  <a:ext uri="{0D108BD9-81ED-4DB2-BD59-A6C34878D82A}">
+                    <a16:rowId xmlns:a16="http://schemas.microsoft.com/office/drawing/2014/main" val="10000"/>
+                  </a:ext>
+                </a:extLst>
               </a:tr>
               <a:tr h="0">
                 <a:tc>
@@ -3543,7 +3337,7 @@
                     <a:bodyPr/>
                     <a:lstStyle/>
                     <a:p>
-                      <a:pPr indent="0" marL="0">
+                      <a:pPr marL="0" indent="0">
                         <a:buNone/>
                       </a:pPr>
                       <a:r>
@@ -3564,7 +3358,7 @@
                       </a:endParaRPr>
                     </a:p>
                   </a:txBody>
-                  <a:tcPr marL="91440" marR="91440" marT="45720" marB="45720">
+                  <a:tcPr>
                     <a:lnL w="6350" cap="flat" cmpd="sng" algn="ctr">
                       <a:solidFill>
                         <a:srgbClr val="E2E8F0"/>
@@ -3611,7 +3405,7 @@
                     <a:bodyPr/>
                     <a:lstStyle/>
                     <a:p>
-                      <a:pPr indent="0" marL="0">
+                      <a:pPr marL="0" indent="0">
                         <a:buNone/>
                       </a:pPr>
                       <a:r>
@@ -3632,7 +3426,7 @@
                       </a:endParaRPr>
                     </a:p>
                   </a:txBody>
-                  <a:tcPr marL="91440" marR="91440" marT="45720" marB="45720">
+                  <a:tcPr>
                     <a:lnL w="6350" cap="flat" cmpd="sng" algn="ctr">
                       <a:solidFill>
                         <a:srgbClr val="E2E8F0"/>
@@ -3679,7 +3473,7 @@
                     <a:bodyPr/>
                     <a:lstStyle/>
                     <a:p>
-                      <a:pPr indent="0" marL="0">
+                      <a:pPr marL="0" indent="0">
                         <a:buNone/>
                       </a:pPr>
                       <a:r>
@@ -3700,7 +3494,7 @@
                       </a:endParaRPr>
                     </a:p>
                   </a:txBody>
-                  <a:tcPr marL="91440" marR="91440" marT="45720" marB="45720">
+                  <a:tcPr>
                     <a:lnL w="6350" cap="flat" cmpd="sng" algn="ctr">
                       <a:solidFill>
                         <a:srgbClr val="E2E8F0"/>
@@ -3747,7 +3541,7 @@
                     <a:bodyPr/>
                     <a:lstStyle/>
                     <a:p>
-                      <a:pPr indent="0" marL="0">
+                      <a:pPr marL="0" indent="0">
                         <a:buNone/>
                       </a:pPr>
                       <a:r>
@@ -3768,7 +3562,7 @@
                       </a:endParaRPr>
                     </a:p>
                   </a:txBody>
-                  <a:tcPr marL="91440" marR="91440" marT="45720" marB="45720">
+                  <a:tcPr>
                     <a:lnL w="6350" cap="flat" cmpd="sng" algn="ctr">
                       <a:solidFill>
                         <a:srgbClr val="E2E8F0"/>
@@ -3815,7 +3609,7 @@
                     <a:bodyPr/>
                     <a:lstStyle/>
                     <a:p>
-                      <a:pPr indent="0" marL="0">
+                      <a:pPr marL="0" indent="0">
                         <a:buNone/>
                       </a:pPr>
                       <a:r>
@@ -3836,7 +3630,7 @@
                       </a:endParaRPr>
                     </a:p>
                   </a:txBody>
-                  <a:tcPr marL="91440" marR="91440" marT="45720" marB="45720">
+                  <a:tcPr>
                     <a:lnL w="6350" cap="flat" cmpd="sng" algn="ctr">
                       <a:solidFill>
                         <a:srgbClr val="E2E8F0"/>
@@ -3883,7 +3677,7 @@
                     <a:bodyPr/>
                     <a:lstStyle/>
                     <a:p>
-                      <a:pPr indent="0" marL="0">
+                      <a:pPr marL="0" indent="0">
                         <a:buNone/>
                       </a:pPr>
                       <a:r>
@@ -3904,7 +3698,7 @@
                       </a:endParaRPr>
                     </a:p>
                   </a:txBody>
-                  <a:tcPr marL="91440" marR="91440" marT="45720" marB="45720">
+                  <a:tcPr>
                     <a:lnL w="6350" cap="flat" cmpd="sng" algn="ctr">
                       <a:solidFill>
                         <a:srgbClr val="E2E8F0"/>
@@ -3946,6 +3740,11 @@
                     </a:solidFill>
                   </a:tcPr>
                 </a:tc>
+                <a:extLst>
+                  <a:ext uri="{0D108BD9-81ED-4DB2-BD59-A6C34878D82A}">
+                    <a16:rowId xmlns:a16="http://schemas.microsoft.com/office/drawing/2014/main" val="10001"/>
+                  </a:ext>
+                </a:extLst>
               </a:tr>
               <a:tr h="0">
                 <a:tc>
@@ -3953,7 +3752,7 @@
                     <a:bodyPr/>
                     <a:lstStyle/>
                     <a:p>
-                      <a:pPr indent="0" marL="0">
+                      <a:pPr marL="0" indent="0">
                         <a:buNone/>
                       </a:pPr>
                       <a:r>
@@ -3974,7 +3773,7 @@
                       </a:endParaRPr>
                     </a:p>
                   </a:txBody>
-                  <a:tcPr marL="91440" marR="91440" marT="45720" marB="45720">
+                  <a:tcPr>
                     <a:lnL w="6350" cap="flat" cmpd="sng" algn="ctr">
                       <a:solidFill>
                         <a:srgbClr val="E2E8F0"/>
@@ -4021,7 +3820,7 @@
                     <a:bodyPr/>
                     <a:lstStyle/>
                     <a:p>
-                      <a:pPr indent="0" marL="0">
+                      <a:pPr marL="0" indent="0">
                         <a:buNone/>
                       </a:pPr>
                       <a:r>
@@ -4042,7 +3841,7 @@
                       </a:endParaRPr>
                     </a:p>
                   </a:txBody>
-                  <a:tcPr marL="91440" marR="91440" marT="45720" marB="45720">
+                  <a:tcPr>
                     <a:lnL w="6350" cap="flat" cmpd="sng" algn="ctr">
                       <a:solidFill>
                         <a:srgbClr val="E2E8F0"/>
@@ -4089,7 +3888,7 @@
                     <a:bodyPr/>
                     <a:lstStyle/>
                     <a:p>
-                      <a:pPr indent="0" marL="0">
+                      <a:pPr marL="0" indent="0">
                         <a:buNone/>
                       </a:pPr>
                       <a:r>
@@ -4110,7 +3909,7 @@
                       </a:endParaRPr>
                     </a:p>
                   </a:txBody>
-                  <a:tcPr marL="91440" marR="91440" marT="45720" marB="45720">
+                  <a:tcPr>
                     <a:lnL w="6350" cap="flat" cmpd="sng" algn="ctr">
                       <a:solidFill>
                         <a:srgbClr val="E2E8F0"/>
@@ -4157,7 +3956,7 @@
                     <a:bodyPr/>
                     <a:lstStyle/>
                     <a:p>
-                      <a:pPr indent="0" marL="0">
+                      <a:pPr marL="0" indent="0">
                         <a:buNone/>
                       </a:pPr>
                       <a:r>
@@ -4178,7 +3977,7 @@
                       </a:endParaRPr>
                     </a:p>
                   </a:txBody>
-                  <a:tcPr marL="91440" marR="91440" marT="45720" marB="45720">
+                  <a:tcPr>
                     <a:lnL w="6350" cap="flat" cmpd="sng" algn="ctr">
                       <a:solidFill>
                         <a:srgbClr val="E2E8F0"/>
@@ -4225,7 +4024,7 @@
                     <a:bodyPr/>
                     <a:lstStyle/>
                     <a:p>
-                      <a:pPr indent="0" marL="0">
+                      <a:pPr marL="0" indent="0">
                         <a:buNone/>
                       </a:pPr>
                       <a:r>
@@ -4246,7 +4045,7 @@
                       </a:endParaRPr>
                     </a:p>
                   </a:txBody>
-                  <a:tcPr marL="91440" marR="91440" marT="45720" marB="45720">
+                  <a:tcPr>
                     <a:lnL w="6350" cap="flat" cmpd="sng" algn="ctr">
                       <a:solidFill>
                         <a:srgbClr val="E2E8F0"/>
@@ -4293,7 +4092,7 @@
                     <a:bodyPr/>
                     <a:lstStyle/>
                     <a:p>
-                      <a:pPr indent="0" marL="0">
+                      <a:pPr marL="0" indent="0">
                         <a:buNone/>
                       </a:pPr>
                       <a:r>
@@ -4314,7 +4113,7 @@
                       </a:endParaRPr>
                     </a:p>
                   </a:txBody>
-                  <a:tcPr marL="91440" marR="91440" marT="45720" marB="45720">
+                  <a:tcPr>
                     <a:lnL w="6350" cap="flat" cmpd="sng" algn="ctr">
                       <a:solidFill>
                         <a:srgbClr val="E2E8F0"/>
@@ -4356,6 +4155,11 @@
                     </a:solidFill>
                   </a:tcPr>
                 </a:tc>
+                <a:extLst>
+                  <a:ext uri="{0D108BD9-81ED-4DB2-BD59-A6C34878D82A}">
+                    <a16:rowId xmlns:a16="http://schemas.microsoft.com/office/drawing/2014/main" val="10002"/>
+                  </a:ext>
+                </a:extLst>
               </a:tr>
               <a:tr h="0">
                 <a:tc>
@@ -4363,7 +4167,7 @@
                     <a:bodyPr/>
                     <a:lstStyle/>
                     <a:p>
-                      <a:pPr indent="0" marL="0">
+                      <a:pPr marL="0" indent="0">
                         <a:buNone/>
                       </a:pPr>
                       <a:r>
@@ -4384,7 +4188,7 @@
                       </a:endParaRPr>
                     </a:p>
                   </a:txBody>
-                  <a:tcPr marL="91440" marR="91440" marT="45720" marB="45720">
+                  <a:tcPr>
                     <a:lnL w="6350" cap="flat" cmpd="sng" algn="ctr">
                       <a:solidFill>
                         <a:srgbClr val="E2E8F0"/>
@@ -4431,7 +4235,7 @@
                     <a:bodyPr/>
                     <a:lstStyle/>
                     <a:p>
-                      <a:pPr indent="0" marL="0">
+                      <a:pPr marL="0" indent="0">
                         <a:buNone/>
                       </a:pPr>
                       <a:r>
@@ -4452,7 +4256,7 @@
                       </a:endParaRPr>
                     </a:p>
                   </a:txBody>
-                  <a:tcPr marL="91440" marR="91440" marT="45720" marB="45720">
+                  <a:tcPr>
                     <a:lnL w="6350" cap="flat" cmpd="sng" algn="ctr">
                       <a:solidFill>
                         <a:srgbClr val="E2E8F0"/>
@@ -4499,7 +4303,7 @@
                     <a:bodyPr/>
                     <a:lstStyle/>
                     <a:p>
-                      <a:pPr indent="0" marL="0">
+                      <a:pPr marL="0" indent="0">
                         <a:buNone/>
                       </a:pPr>
                       <a:r>
@@ -4520,7 +4324,7 @@
                       </a:endParaRPr>
                     </a:p>
                   </a:txBody>
-                  <a:tcPr marL="91440" marR="91440" marT="45720" marB="45720">
+                  <a:tcPr>
                     <a:lnL w="6350" cap="flat" cmpd="sng" algn="ctr">
                       <a:solidFill>
                         <a:srgbClr val="E2E8F0"/>
@@ -4567,7 +4371,7 @@
                     <a:bodyPr/>
                     <a:lstStyle/>
                     <a:p>
-                      <a:pPr indent="0" marL="0">
+                      <a:pPr marL="0" indent="0">
                         <a:buNone/>
                       </a:pPr>
                       <a:r>
@@ -4588,7 +4392,7 @@
                       </a:endParaRPr>
                     </a:p>
                   </a:txBody>
-                  <a:tcPr marL="91440" marR="91440" marT="45720" marB="45720">
+                  <a:tcPr>
                     <a:lnL w="6350" cap="flat" cmpd="sng" algn="ctr">
                       <a:solidFill>
                         <a:srgbClr val="E2E8F0"/>
@@ -4635,7 +4439,7 @@
                     <a:bodyPr/>
                     <a:lstStyle/>
                     <a:p>
-                      <a:pPr indent="0" marL="0">
+                      <a:pPr marL="0" indent="0">
                         <a:buNone/>
                       </a:pPr>
                       <a:r>
@@ -4656,7 +4460,7 @@
                       </a:endParaRPr>
                     </a:p>
                   </a:txBody>
-                  <a:tcPr marL="91440" marR="91440" marT="45720" marB="45720">
+                  <a:tcPr>
                     <a:lnL w="6350" cap="flat" cmpd="sng" algn="ctr">
                       <a:solidFill>
                         <a:srgbClr val="E2E8F0"/>
@@ -4703,7 +4507,7 @@
                     <a:bodyPr/>
                     <a:lstStyle/>
                     <a:p>
-                      <a:pPr indent="0" marL="0">
+                      <a:pPr marL="0" indent="0">
                         <a:buNone/>
                       </a:pPr>
                       <a:r>
@@ -4724,7 +4528,7 @@
                       </a:endParaRPr>
                     </a:p>
                   </a:txBody>
-                  <a:tcPr marL="91440" marR="91440" marT="45720" marB="45720">
+                  <a:tcPr>
                     <a:lnL w="6350" cap="flat" cmpd="sng" algn="ctr">
                       <a:solidFill>
                         <a:srgbClr val="E2E8F0"/>
@@ -4766,6 +4570,11 @@
                     </a:solidFill>
                   </a:tcPr>
                 </a:tc>
+                <a:extLst>
+                  <a:ext uri="{0D108BD9-81ED-4DB2-BD59-A6C34878D82A}">
+                    <a16:rowId xmlns:a16="http://schemas.microsoft.com/office/drawing/2014/main" val="10003"/>
+                  </a:ext>
+                </a:extLst>
               </a:tr>
               <a:tr h="0">
                 <a:tc>
@@ -4773,7 +4582,7 @@
                     <a:bodyPr/>
                     <a:lstStyle/>
                     <a:p>
-                      <a:pPr indent="0" marL="0">
+                      <a:pPr marL="0" indent="0">
                         <a:buNone/>
                       </a:pPr>
                       <a:r>
@@ -4794,7 +4603,7 @@
                       </a:endParaRPr>
                     </a:p>
                   </a:txBody>
-                  <a:tcPr marL="91440" marR="91440" marT="45720" marB="45720">
+                  <a:tcPr>
                     <a:lnL w="6350" cap="flat" cmpd="sng" algn="ctr">
                       <a:solidFill>
                         <a:srgbClr val="E2E8F0"/>
@@ -4841,7 +4650,7 @@
                     <a:bodyPr/>
                     <a:lstStyle/>
                     <a:p>
-                      <a:pPr indent="0" marL="0">
+                      <a:pPr marL="0" indent="0">
                         <a:buNone/>
                       </a:pPr>
                       <a:r>
@@ -4862,7 +4671,7 @@
                       </a:endParaRPr>
                     </a:p>
                   </a:txBody>
-                  <a:tcPr marL="91440" marR="91440" marT="45720" marB="45720">
+                  <a:tcPr>
                     <a:lnL w="6350" cap="flat" cmpd="sng" algn="ctr">
                       <a:solidFill>
                         <a:srgbClr val="E2E8F0"/>
@@ -4909,7 +4718,7 @@
                     <a:bodyPr/>
                     <a:lstStyle/>
                     <a:p>
-                      <a:pPr indent="0" marL="0">
+                      <a:pPr marL="0" indent="0">
                         <a:buNone/>
                       </a:pPr>
                       <a:r>
@@ -4930,7 +4739,7 @@
                       </a:endParaRPr>
                     </a:p>
                   </a:txBody>
-                  <a:tcPr marL="91440" marR="91440" marT="45720" marB="45720">
+                  <a:tcPr>
                     <a:lnL w="6350" cap="flat" cmpd="sng" algn="ctr">
                       <a:solidFill>
                         <a:srgbClr val="E2E8F0"/>
@@ -4977,7 +4786,7 @@
                     <a:bodyPr/>
                     <a:lstStyle/>
                     <a:p>
-                      <a:pPr indent="0" marL="0">
+                      <a:pPr marL="0" indent="0">
                         <a:buNone/>
                       </a:pPr>
                       <a:r>
@@ -4998,7 +4807,7 @@
                       </a:endParaRPr>
                     </a:p>
                   </a:txBody>
-                  <a:tcPr marL="91440" marR="91440" marT="45720" marB="45720">
+                  <a:tcPr>
                     <a:lnL w="6350" cap="flat" cmpd="sng" algn="ctr">
                       <a:solidFill>
                         <a:srgbClr val="E2E8F0"/>
@@ -5045,7 +4854,7 @@
                     <a:bodyPr/>
                     <a:lstStyle/>
                     <a:p>
-                      <a:pPr indent="0" marL="0">
+                      <a:pPr marL="0" indent="0">
                         <a:buNone/>
                       </a:pPr>
                       <a:r>
@@ -5066,7 +4875,7 @@
                       </a:endParaRPr>
                     </a:p>
                   </a:txBody>
-                  <a:tcPr marL="91440" marR="91440" marT="45720" marB="45720">
+                  <a:tcPr>
                     <a:lnL w="6350" cap="flat" cmpd="sng" algn="ctr">
                       <a:solidFill>
                         <a:srgbClr val="E2E8F0"/>
@@ -5113,7 +4922,7 @@
                     <a:bodyPr/>
                     <a:lstStyle/>
                     <a:p>
-                      <a:pPr indent="0" marL="0">
+                      <a:pPr marL="0" indent="0">
                         <a:buNone/>
                       </a:pPr>
                       <a:r>
@@ -5134,7 +4943,7 @@
                       </a:endParaRPr>
                     </a:p>
                   </a:txBody>
-                  <a:tcPr marL="91440" marR="91440" marT="45720" marB="45720">
+                  <a:tcPr>
                     <a:lnL w="6350" cap="flat" cmpd="sng" algn="ctr">
                       <a:solidFill>
                         <a:srgbClr val="E2E8F0"/>
@@ -5176,6 +4985,11 @@
                     </a:solidFill>
                   </a:tcPr>
                 </a:tc>
+                <a:extLst>
+                  <a:ext uri="{0D108BD9-81ED-4DB2-BD59-A6C34878D82A}">
+                    <a16:rowId xmlns:a16="http://schemas.microsoft.com/office/drawing/2014/main" val="10004"/>
+                  </a:ext>
+                </a:extLst>
               </a:tr>
               <a:tr h="0">
                 <a:tc>
@@ -5183,7 +4997,7 @@
                     <a:bodyPr/>
                     <a:lstStyle/>
                     <a:p>
-                      <a:pPr indent="0" marL="0">
+                      <a:pPr marL="0" indent="0">
                         <a:buNone/>
                       </a:pPr>
                       <a:r>
@@ -5204,7 +5018,7 @@
                       </a:endParaRPr>
                     </a:p>
                   </a:txBody>
-                  <a:tcPr marL="91440" marR="91440" marT="45720" marB="45720">
+                  <a:tcPr>
                     <a:lnL w="6350" cap="flat" cmpd="sng" algn="ctr">
                       <a:solidFill>
                         <a:srgbClr val="E2E8F0"/>
@@ -5251,7 +5065,7 @@
                     <a:bodyPr/>
                     <a:lstStyle/>
                     <a:p>
-                      <a:pPr indent="0" marL="0">
+                      <a:pPr marL="0" indent="0">
                         <a:buNone/>
                       </a:pPr>
                       <a:r>
@@ -5272,7 +5086,7 @@
                       </a:endParaRPr>
                     </a:p>
                   </a:txBody>
-                  <a:tcPr marL="91440" marR="91440" marT="45720" marB="45720">
+                  <a:tcPr>
                     <a:lnL w="6350" cap="flat" cmpd="sng" algn="ctr">
                       <a:solidFill>
                         <a:srgbClr val="E2E8F0"/>
@@ -5319,7 +5133,7 @@
                     <a:bodyPr/>
                     <a:lstStyle/>
                     <a:p>
-                      <a:pPr indent="0" marL="0">
+                      <a:pPr marL="0" indent="0">
                         <a:buNone/>
                       </a:pPr>
                       <a:r>
@@ -5340,7 +5154,7 @@
                       </a:endParaRPr>
                     </a:p>
                   </a:txBody>
-                  <a:tcPr marL="91440" marR="91440" marT="45720" marB="45720">
+                  <a:tcPr>
                     <a:lnL w="6350" cap="flat" cmpd="sng" algn="ctr">
                       <a:solidFill>
                         <a:srgbClr val="E2E8F0"/>
@@ -5387,7 +5201,7 @@
                     <a:bodyPr/>
                     <a:lstStyle/>
                     <a:p>
-                      <a:pPr indent="0" marL="0">
+                      <a:pPr marL="0" indent="0">
                         <a:buNone/>
                       </a:pPr>
                       <a:r>
@@ -5408,7 +5222,7 @@
                       </a:endParaRPr>
                     </a:p>
                   </a:txBody>
-                  <a:tcPr marL="91440" marR="91440" marT="45720" marB="45720">
+                  <a:tcPr>
                     <a:lnL w="6350" cap="flat" cmpd="sng" algn="ctr">
                       <a:solidFill>
                         <a:srgbClr val="E2E8F0"/>
@@ -5455,7 +5269,7 @@
                     <a:bodyPr/>
                     <a:lstStyle/>
                     <a:p>
-                      <a:pPr indent="0" marL="0">
+                      <a:pPr marL="0" indent="0">
                         <a:buNone/>
                       </a:pPr>
                       <a:r>
@@ -5476,7 +5290,7 @@
                       </a:endParaRPr>
                     </a:p>
                   </a:txBody>
-                  <a:tcPr marL="91440" marR="91440" marT="45720" marB="45720">
+                  <a:tcPr>
                     <a:lnL w="6350" cap="flat" cmpd="sng" algn="ctr">
                       <a:solidFill>
                         <a:srgbClr val="E2E8F0"/>
@@ -5523,7 +5337,7 @@
                     <a:bodyPr/>
                     <a:lstStyle/>
                     <a:p>
-                      <a:pPr indent="0" marL="0">
+                      <a:pPr marL="0" indent="0">
                         <a:buNone/>
                       </a:pPr>
                       <a:r>
@@ -5544,7 +5358,7 @@
                       </a:endParaRPr>
                     </a:p>
                   </a:txBody>
-                  <a:tcPr marL="91440" marR="91440" marT="45720" marB="45720">
+                  <a:tcPr>
                     <a:lnL w="6350" cap="flat" cmpd="sng" algn="ctr">
                       <a:solidFill>
                         <a:srgbClr val="E2E8F0"/>
@@ -5586,6 +5400,11 @@
                     </a:solidFill>
                   </a:tcPr>
                 </a:tc>
+                <a:extLst>
+                  <a:ext uri="{0D108BD9-81ED-4DB2-BD59-A6C34878D82A}">
+                    <a16:rowId xmlns:a16="http://schemas.microsoft.com/office/drawing/2014/main" val="10005"/>
+                  </a:ext>
+                </a:extLst>
               </a:tr>
               <a:tr h="0">
                 <a:tc>
@@ -5593,7 +5412,7 @@
                     <a:bodyPr/>
                     <a:lstStyle/>
                     <a:p>
-                      <a:pPr indent="0" marL="0">
+                      <a:pPr marL="0" indent="0">
                         <a:buNone/>
                       </a:pPr>
                       <a:r>
@@ -5614,7 +5433,7 @@
                       </a:endParaRPr>
                     </a:p>
                   </a:txBody>
-                  <a:tcPr marL="91440" marR="91440" marT="45720" marB="45720">
+                  <a:tcPr>
                     <a:lnL w="6350" cap="flat" cmpd="sng" algn="ctr">
                       <a:solidFill>
                         <a:srgbClr val="E2E8F0"/>
@@ -5661,7 +5480,7 @@
                     <a:bodyPr/>
                     <a:lstStyle/>
                     <a:p>
-                      <a:pPr indent="0" marL="0">
+                      <a:pPr marL="0" indent="0">
                         <a:buNone/>
                       </a:pPr>
                       <a:r>
@@ -5682,7 +5501,7 @@
                       </a:endParaRPr>
                     </a:p>
                   </a:txBody>
-                  <a:tcPr marL="91440" marR="91440" marT="45720" marB="45720">
+                  <a:tcPr>
                     <a:lnL w="6350" cap="flat" cmpd="sng" algn="ctr">
                       <a:solidFill>
                         <a:srgbClr val="E2E8F0"/>
@@ -5729,7 +5548,7 @@
                     <a:bodyPr/>
                     <a:lstStyle/>
                     <a:p>
-                      <a:pPr indent="0" marL="0">
+                      <a:pPr marL="0" indent="0">
                         <a:buNone/>
                       </a:pPr>
                       <a:r>
@@ -5750,7 +5569,7 @@
                       </a:endParaRPr>
                     </a:p>
                   </a:txBody>
-                  <a:tcPr marL="91440" marR="91440" marT="45720" marB="45720">
+                  <a:tcPr>
                     <a:lnL w="6350" cap="flat" cmpd="sng" algn="ctr">
                       <a:solidFill>
                         <a:srgbClr val="E2E8F0"/>
@@ -5797,7 +5616,7 @@
                     <a:bodyPr/>
                     <a:lstStyle/>
                     <a:p>
-                      <a:pPr indent="0" marL="0">
+                      <a:pPr marL="0" indent="0">
                         <a:buNone/>
                       </a:pPr>
                       <a:r>
@@ -5818,7 +5637,7 @@
                       </a:endParaRPr>
                     </a:p>
                   </a:txBody>
-                  <a:tcPr marL="91440" marR="91440" marT="45720" marB="45720">
+                  <a:tcPr>
                     <a:lnL w="6350" cap="flat" cmpd="sng" algn="ctr">
                       <a:solidFill>
                         <a:srgbClr val="E2E8F0"/>
@@ -5865,7 +5684,7 @@
                     <a:bodyPr/>
                     <a:lstStyle/>
                     <a:p>
-                      <a:pPr indent="0" marL="0">
+                      <a:pPr marL="0" indent="0">
                         <a:buNone/>
                       </a:pPr>
                       <a:r>
@@ -5886,7 +5705,7 @@
                       </a:endParaRPr>
                     </a:p>
                   </a:txBody>
-                  <a:tcPr marL="91440" marR="91440" marT="45720" marB="45720">
+                  <a:tcPr>
                     <a:lnL w="6350" cap="flat" cmpd="sng" algn="ctr">
                       <a:solidFill>
                         <a:srgbClr val="E2E8F0"/>
@@ -5933,7 +5752,7 @@
                     <a:bodyPr/>
                     <a:lstStyle/>
                     <a:p>
-                      <a:pPr indent="0" marL="0">
+                      <a:pPr marL="0" indent="0">
                         <a:buNone/>
                       </a:pPr>
                       <a:r>
@@ -5954,7 +5773,7 @@
                       </a:endParaRPr>
                     </a:p>
                   </a:txBody>
-                  <a:tcPr marL="91440" marR="91440" marT="45720" marB="45720">
+                  <a:tcPr>
                     <a:lnL w="6350" cap="flat" cmpd="sng" algn="ctr">
                       <a:solidFill>
                         <a:srgbClr val="E2E8F0"/>
@@ -5996,6 +5815,11 @@
                     </a:solidFill>
                   </a:tcPr>
                 </a:tc>
+                <a:extLst>
+                  <a:ext uri="{0D108BD9-81ED-4DB2-BD59-A6C34878D82A}">
+                    <a16:rowId xmlns:a16="http://schemas.microsoft.com/office/drawing/2014/main" val="10006"/>
+                  </a:ext>
+                </a:extLst>
               </a:tr>
               <a:tr h="0">
                 <a:tc>
@@ -6003,7 +5827,7 @@
                     <a:bodyPr/>
                     <a:lstStyle/>
                     <a:p>
-                      <a:pPr indent="0" marL="0">
+                      <a:pPr marL="0" indent="0">
                         <a:buNone/>
                       </a:pPr>
                       <a:r>
@@ -6024,7 +5848,7 @@
                       </a:endParaRPr>
                     </a:p>
                   </a:txBody>
-                  <a:tcPr marL="91440" marR="91440" marT="45720" marB="45720">
+                  <a:tcPr>
                     <a:lnL w="6350" cap="flat" cmpd="sng" algn="ctr">
                       <a:solidFill>
                         <a:srgbClr val="E2E8F0"/>
@@ -6071,7 +5895,7 @@
                     <a:bodyPr/>
                     <a:lstStyle/>
                     <a:p>
-                      <a:pPr indent="0" marL="0">
+                      <a:pPr marL="0" indent="0">
                         <a:buNone/>
                       </a:pPr>
                       <a:r>
@@ -6092,7 +5916,7 @@
                       </a:endParaRPr>
                     </a:p>
                   </a:txBody>
-                  <a:tcPr marL="91440" marR="91440" marT="45720" marB="45720">
+                  <a:tcPr>
                     <a:lnL w="6350" cap="flat" cmpd="sng" algn="ctr">
                       <a:solidFill>
                         <a:srgbClr val="E2E8F0"/>
@@ -6139,7 +5963,7 @@
                     <a:bodyPr/>
                     <a:lstStyle/>
                     <a:p>
-                      <a:pPr indent="0" marL="0">
+                      <a:pPr marL="0" indent="0">
                         <a:buNone/>
                       </a:pPr>
                       <a:r>
@@ -6160,7 +5984,7 @@
                       </a:endParaRPr>
                     </a:p>
                   </a:txBody>
-                  <a:tcPr marL="91440" marR="91440" marT="45720" marB="45720">
+                  <a:tcPr>
                     <a:lnL w="6350" cap="flat" cmpd="sng" algn="ctr">
                       <a:solidFill>
                         <a:srgbClr val="E2E8F0"/>
@@ -6207,7 +6031,7 @@
                     <a:bodyPr/>
                     <a:lstStyle/>
                     <a:p>
-                      <a:pPr indent="0" marL="0">
+                      <a:pPr marL="0" indent="0">
                         <a:buNone/>
                       </a:pPr>
                       <a:r>
@@ -6228,7 +6052,7 @@
                       </a:endParaRPr>
                     </a:p>
                   </a:txBody>
-                  <a:tcPr marL="91440" marR="91440" marT="45720" marB="45720">
+                  <a:tcPr>
                     <a:lnL w="6350" cap="flat" cmpd="sng" algn="ctr">
                       <a:solidFill>
                         <a:srgbClr val="E2E8F0"/>
@@ -6275,7 +6099,7 @@
                     <a:bodyPr/>
                     <a:lstStyle/>
                     <a:p>
-                      <a:pPr indent="0" marL="0">
+                      <a:pPr marL="0" indent="0">
                         <a:buNone/>
                       </a:pPr>
                       <a:r>
@@ -6296,7 +6120,7 @@
                       </a:endParaRPr>
                     </a:p>
                   </a:txBody>
-                  <a:tcPr marL="91440" marR="91440" marT="45720" marB="45720">
+                  <a:tcPr>
                     <a:lnL w="6350" cap="flat" cmpd="sng" algn="ctr">
                       <a:solidFill>
                         <a:srgbClr val="E2E8F0"/>
@@ -6343,7 +6167,7 @@
                     <a:bodyPr/>
                     <a:lstStyle/>
                     <a:p>
-                      <a:pPr indent="0" marL="0">
+                      <a:pPr marL="0" indent="0">
                         <a:buNone/>
                       </a:pPr>
                       <a:r>
@@ -6364,7 +6188,7 @@
                       </a:endParaRPr>
                     </a:p>
                   </a:txBody>
-                  <a:tcPr marL="91440" marR="91440" marT="45720" marB="45720">
+                  <a:tcPr>
                     <a:lnL w="6350" cap="flat" cmpd="sng" algn="ctr">
                       <a:solidFill>
                         <a:srgbClr val="E2E8F0"/>
@@ -6406,6 +6230,11 @@
                     </a:solidFill>
                   </a:tcPr>
                 </a:tc>
+                <a:extLst>
+                  <a:ext uri="{0D108BD9-81ED-4DB2-BD59-A6C34878D82A}">
+                    <a16:rowId xmlns:a16="http://schemas.microsoft.com/office/drawing/2014/main" val="10007"/>
+                  </a:ext>
+                </a:extLst>
               </a:tr>
             </a:tbl>
           </a:graphicData>
@@ -6427,6 +6256,7 @@
         <a:solidFill>
           <a:srgbClr val="FFFFFF"/>
         </a:solidFill>
+        <a:effectLst/>
       </p:bgPr>
     </p:bg>
     <p:spTree>
@@ -6464,7 +6294,7 @@
           <a:bodyPr wrap="square" lIns="0" tIns="0" rIns="0" bIns="0" rtlCol="0" anchor="ctr"/>
           <a:lstStyle/>
           <a:p>
-            <a:pPr indent="0" marL="0">
+            <a:pPr marL="0" indent="0">
               <a:buNone/>
             </a:pPr>
             <a:r>
@@ -6510,7 +6340,7 @@
         </p:nvSpPr>
         <p:spPr>
           <a:xfrm>
-            <a:off x="457200" y="1097280"/>
+            <a:off x="457200" y="863013"/>
             <a:ext cx="1828800" cy="320040"/>
           </a:xfrm>
           <a:prstGeom prst="rect">
@@ -6523,7 +6353,7 @@
           <a:bodyPr wrap="square" rtlCol="0" anchor="ctr"/>
           <a:lstStyle/>
           <a:p>
-            <a:pPr indent="0" marL="0">
+            <a:pPr marL="0" indent="0">
               <a:buNone/>
             </a:pPr>
             <a:r>
@@ -6549,7 +6379,7 @@
         </p:nvSpPr>
         <p:spPr>
           <a:xfrm>
-            <a:off x="2377440" y="1143000"/>
+            <a:off x="2377440" y="908733"/>
             <a:ext cx="4572000" cy="256032"/>
           </a:xfrm>
           <a:prstGeom prst="rect">
@@ -6569,7 +6399,7 @@
         </p:nvSpPr>
         <p:spPr>
           <a:xfrm>
-            <a:off x="2377440" y="1143000"/>
+            <a:off x="2377440" y="908733"/>
             <a:ext cx="4174236" cy="256032"/>
           </a:xfrm>
           <a:prstGeom prst="rect">
@@ -6580,6 +6410,13 @@
           </a:solidFill>
           <a:ln/>
         </p:spPr>
+        <p:txBody>
+          <a:bodyPr/>
+          <a:lstStyle/>
+          <a:p>
+            <a:endParaRPr lang="fr-FR" dirty="0"/>
+          </a:p>
+        </p:txBody>
       </p:sp>
       <p:sp>
         <p:nvSpPr>
@@ -6589,7 +6426,7 @@
         </p:nvSpPr>
         <p:spPr>
           <a:xfrm>
-            <a:off x="7132320" y="1097280"/>
+            <a:off x="7132320" y="863013"/>
             <a:ext cx="914400" cy="320040"/>
           </a:xfrm>
           <a:prstGeom prst="rect">
@@ -6602,7 +6439,7 @@
           <a:bodyPr wrap="square" rtlCol="0" anchor="ctr"/>
           <a:lstStyle/>
           <a:p>
-            <a:pPr algn="r" indent="0" marL="0">
+            <a:pPr marL="0" indent="0" algn="r">
               <a:buNone/>
             </a:pPr>
             <a:r>
@@ -6628,7 +6465,7 @@
         </p:nvSpPr>
         <p:spPr>
           <a:xfrm>
-            <a:off x="457200" y="1783080"/>
+            <a:off x="457200" y="1223862"/>
             <a:ext cx="1828800" cy="320040"/>
           </a:xfrm>
           <a:prstGeom prst="rect">
@@ -6641,7 +6478,7 @@
           <a:bodyPr wrap="square" rtlCol="0" anchor="ctr"/>
           <a:lstStyle/>
           <a:p>
-            <a:pPr indent="0" marL="0">
+            <a:pPr marL="0" indent="0">
               <a:buNone/>
             </a:pPr>
             <a:r>
@@ -6667,7 +6504,7 @@
         </p:nvSpPr>
         <p:spPr>
           <a:xfrm>
-            <a:off x="2377440" y="1828800"/>
+            <a:off x="2377440" y="1269582"/>
             <a:ext cx="4572000" cy="256032"/>
           </a:xfrm>
           <a:prstGeom prst="rect">
@@ -6687,7 +6524,7 @@
         </p:nvSpPr>
         <p:spPr>
           <a:xfrm>
-            <a:off x="2377440" y="1828800"/>
+            <a:off x="2377440" y="1269582"/>
             <a:ext cx="3982212" cy="256032"/>
           </a:xfrm>
           <a:prstGeom prst="rect">
@@ -6707,7 +6544,7 @@
         </p:nvSpPr>
         <p:spPr>
           <a:xfrm>
-            <a:off x="7132320" y="1783080"/>
+            <a:off x="7132320" y="1223862"/>
             <a:ext cx="914400" cy="320040"/>
           </a:xfrm>
           <a:prstGeom prst="rect">
@@ -6720,7 +6557,7 @@
           <a:bodyPr wrap="square" rtlCol="0" anchor="ctr"/>
           <a:lstStyle/>
           <a:p>
-            <a:pPr algn="r" indent="0" marL="0">
+            <a:pPr marL="0" indent="0" algn="r">
               <a:buNone/>
             </a:pPr>
             <a:r>
@@ -6746,7 +6583,7 @@
         </p:nvSpPr>
         <p:spPr>
           <a:xfrm>
-            <a:off x="457200" y="2468880"/>
+            <a:off x="457200" y="1577154"/>
             <a:ext cx="1828800" cy="320040"/>
           </a:xfrm>
           <a:prstGeom prst="rect">
@@ -6759,7 +6596,7 @@
           <a:bodyPr wrap="square" rtlCol="0" anchor="ctr"/>
           <a:lstStyle/>
           <a:p>
-            <a:pPr indent="0" marL="0">
+            <a:pPr marL="0" indent="0">
               <a:buNone/>
             </a:pPr>
             <a:r>
@@ -6785,7 +6622,7 @@
         </p:nvSpPr>
         <p:spPr>
           <a:xfrm>
-            <a:off x="2377440" y="2514600"/>
+            <a:off x="2377440" y="1622874"/>
             <a:ext cx="4572000" cy="256032"/>
           </a:xfrm>
           <a:prstGeom prst="rect">
@@ -6805,7 +6642,7 @@
         </p:nvSpPr>
         <p:spPr>
           <a:xfrm>
-            <a:off x="2377440" y="2514600"/>
+            <a:off x="2377440" y="1622874"/>
             <a:ext cx="4192524" cy="256032"/>
           </a:xfrm>
           <a:prstGeom prst="rect">
@@ -6825,7 +6662,7 @@
         </p:nvSpPr>
         <p:spPr>
           <a:xfrm>
-            <a:off x="7132320" y="2468880"/>
+            <a:off x="7132320" y="1577154"/>
             <a:ext cx="914400" cy="320040"/>
           </a:xfrm>
           <a:prstGeom prst="rect">
@@ -6838,7 +6675,7 @@
           <a:bodyPr wrap="square" rtlCol="0" anchor="ctr"/>
           <a:lstStyle/>
           <a:p>
-            <a:pPr algn="r" indent="0" marL="0">
+            <a:pPr marL="0" indent="0" algn="r">
               <a:buNone/>
             </a:pPr>
             <a:r>
@@ -6864,7 +6701,7 @@
         </p:nvSpPr>
         <p:spPr>
           <a:xfrm>
-            <a:off x="457200" y="3154680"/>
+            <a:off x="457200" y="1922889"/>
             <a:ext cx="1828800" cy="320040"/>
           </a:xfrm>
           <a:prstGeom prst="rect">
@@ -6877,7 +6714,7 @@
           <a:bodyPr wrap="square" rtlCol="0" anchor="ctr"/>
           <a:lstStyle/>
           <a:p>
-            <a:pPr indent="0" marL="0">
+            <a:pPr marL="0" indent="0">
               <a:buNone/>
             </a:pPr>
             <a:r>
@@ -6903,7 +6740,7 @@
         </p:nvSpPr>
         <p:spPr>
           <a:xfrm>
-            <a:off x="2377440" y="3200400"/>
+            <a:off x="2377440" y="1968609"/>
             <a:ext cx="4572000" cy="256032"/>
           </a:xfrm>
           <a:prstGeom prst="rect">
@@ -6923,7 +6760,7 @@
         </p:nvSpPr>
         <p:spPr>
           <a:xfrm>
-            <a:off x="2377440" y="3200400"/>
+            <a:off x="2377440" y="1968609"/>
             <a:ext cx="3602736" cy="256032"/>
           </a:xfrm>
           <a:prstGeom prst="rect">
@@ -6943,7 +6780,7 @@
         </p:nvSpPr>
         <p:spPr>
           <a:xfrm>
-            <a:off x="7132320" y="3154680"/>
+            <a:off x="7132320" y="1922889"/>
             <a:ext cx="914400" cy="320040"/>
           </a:xfrm>
           <a:prstGeom prst="rect">
@@ -6956,7 +6793,7 @@
           <a:bodyPr wrap="square" rtlCol="0" anchor="ctr"/>
           <a:lstStyle/>
           <a:p>
-            <a:pPr algn="r" indent="0" marL="0">
+            <a:pPr marL="0" indent="0" algn="r">
               <a:buNone/>
             </a:pPr>
             <a:r>
@@ -6982,7 +6819,7 @@
         </p:nvSpPr>
         <p:spPr>
           <a:xfrm>
-            <a:off x="457200" y="3840480"/>
+            <a:off x="457200" y="2261067"/>
             <a:ext cx="1828800" cy="320040"/>
           </a:xfrm>
           <a:prstGeom prst="rect">
@@ -6995,7 +6832,7 @@
           <a:bodyPr wrap="square" rtlCol="0" anchor="ctr"/>
           <a:lstStyle/>
           <a:p>
-            <a:pPr indent="0" marL="0">
+            <a:pPr marL="0" indent="0">
               <a:buNone/>
             </a:pPr>
             <a:r>
@@ -7021,7 +6858,7 @@
         </p:nvSpPr>
         <p:spPr>
           <a:xfrm>
-            <a:off x="2377440" y="3886200"/>
+            <a:off x="2377440" y="2306787"/>
             <a:ext cx="4572000" cy="256032"/>
           </a:xfrm>
           <a:prstGeom prst="rect">
@@ -7041,7 +6878,7 @@
         </p:nvSpPr>
         <p:spPr>
           <a:xfrm>
-            <a:off x="2377440" y="3886200"/>
+            <a:off x="2377440" y="2306787"/>
             <a:ext cx="3396996" cy="256032"/>
           </a:xfrm>
           <a:prstGeom prst="rect">
@@ -7061,7 +6898,7 @@
         </p:nvSpPr>
         <p:spPr>
           <a:xfrm>
-            <a:off x="7132320" y="3840480"/>
+            <a:off x="7132320" y="2261067"/>
             <a:ext cx="914400" cy="320040"/>
           </a:xfrm>
           <a:prstGeom prst="rect">
@@ -7074,7 +6911,7 @@
           <a:bodyPr wrap="square" rtlCol="0" anchor="ctr"/>
           <a:lstStyle/>
           <a:p>
-            <a:pPr algn="r" indent="0" marL="0">
+            <a:pPr marL="0" indent="0" algn="r">
               <a:buNone/>
             </a:pPr>
             <a:r>
@@ -7120,7 +6957,7 @@
         </p:nvSpPr>
         <p:spPr>
           <a:xfrm>
-            <a:off x="457200" y="4709160"/>
+            <a:off x="457200" y="2895480"/>
             <a:ext cx="8229600" cy="365760"/>
           </a:xfrm>
           <a:prstGeom prst="rect">
@@ -7133,7 +6970,7 @@
           <a:bodyPr wrap="square" rtlCol="0" anchor="ctr"/>
           <a:lstStyle/>
           <a:p>
-            <a:pPr indent="0" marL="0">
+            <a:pPr marL="0" indent="0">
               <a:buNone/>
             </a:pPr>
             <a:r>
@@ -7159,7 +6996,7 @@
         </p:nvSpPr>
         <p:spPr>
           <a:xfrm>
-            <a:off x="457200" y="5029200"/>
+            <a:off x="457200" y="3215520"/>
             <a:ext cx="8229600" cy="1371600"/>
           </a:xfrm>
           <a:prstGeom prst="rect">
@@ -7188,17 +7025,33 @@
                 <a:ea typeface="Arial" pitchFamily="34" charset="-122"/>
                 <a:cs typeface="Arial" pitchFamily="34" charset="-120"/>
               </a:rPr>
-              <a:t>331 variantes de nationalite</a:t>
+              <a:t>331 variantes de </a:t>
             </a:r>
-            <a:endParaRPr lang="en-US" sz="1100" dirty="0"/>
-          </a:p>
-          <a:p>
-            <a:pPr indent="0" marL="0">
-              <a:spcAft>
-                <a:spcPts val="400"/>
-              </a:spcAft>
-              <a:buNone/>
-            </a:pPr>
+            <a:r>
+              <a:rPr lang="en-US" sz="1100" dirty="0" err="1">
+                <a:solidFill>
+                  <a:srgbClr val="DC2626"/>
+                </a:solidFill>
+                <a:latin typeface="Arial" pitchFamily="34" charset="0"/>
+                <a:ea typeface="Arial" pitchFamily="34" charset="-122"/>
+                <a:cs typeface="Arial" pitchFamily="34" charset="-120"/>
+              </a:rPr>
+              <a:t>nationalite</a:t>
+            </a:r>
+            <a:br>
+              <a:rPr lang="en-US" sz="1100" dirty="0"/>
+            </a:br>
+            <a:r>
+              <a:rPr lang="en-US" sz="1100" dirty="0" err="1">
+                <a:solidFill>
+                  <a:srgbClr val="64748B"/>
+                </a:solidFill>
+                <a:latin typeface="Arial" pitchFamily="34" charset="0"/>
+                <a:ea typeface="Arial" pitchFamily="34" charset="-122"/>
+                <a:cs typeface="Arial" pitchFamily="34" charset="-120"/>
+              </a:rPr>
+              <a:t>reduites</a:t>
+            </a:r>
             <a:r>
               <a:rPr lang="en-US" sz="1100" dirty="0">
                 <a:solidFill>
@@ -7208,7 +7061,7 @@
                 <a:ea typeface="Arial" pitchFamily="34" charset="-122"/>
                 <a:cs typeface="Arial" pitchFamily="34" charset="-120"/>
               </a:rPr>
-              <a:t> reduites a 52 apres nettoyage (typos, villes, doublons)</a:t>
+              <a:t> a 52 apres nettoyage (typos, villes, doublons)</a:t>
             </a:r>
             <a:endParaRPr lang="en-US" sz="1100" dirty="0"/>
           </a:p>
@@ -7229,17 +7082,44 @@
                 <a:ea typeface="Arial" pitchFamily="34" charset="-122"/>
                 <a:cs typeface="Arial" pitchFamily="34" charset="-120"/>
               </a:rPr>
-              <a:t>35/65 licences avec des ressources manquantes</a:t>
+              <a:t>35/65 licences avec des </a:t>
             </a:r>
-            <a:endParaRPr lang="en-US" sz="1100" dirty="0"/>
-          </a:p>
-          <a:p>
-            <a:pPr indent="0" marL="0">
-              <a:spcAft>
-                <a:spcPts val="400"/>
-              </a:spcAft>
-              <a:buNone/>
-            </a:pPr>
+            <a:r>
+              <a:rPr lang="en-US" sz="1100" dirty="0" err="1">
+                <a:solidFill>
+                  <a:srgbClr val="D97706"/>
+                </a:solidFill>
+                <a:latin typeface="Arial" pitchFamily="34" charset="0"/>
+                <a:ea typeface="Arial" pitchFamily="34" charset="-122"/>
+                <a:cs typeface="Arial" pitchFamily="34" charset="-120"/>
+              </a:rPr>
+              <a:t>ressources</a:t>
+            </a:r>
+            <a:r>
+              <a:rPr lang="en-US" sz="1100" dirty="0">
+                <a:solidFill>
+                  <a:srgbClr val="D97706"/>
+                </a:solidFill>
+                <a:latin typeface="Arial" pitchFamily="34" charset="0"/>
+                <a:ea typeface="Arial" pitchFamily="34" charset="-122"/>
+                <a:cs typeface="Arial" pitchFamily="34" charset="-120"/>
+              </a:rPr>
+              <a:t> </a:t>
+            </a:r>
+            <a:r>
+              <a:rPr lang="en-US" sz="1100" dirty="0" err="1">
+                <a:solidFill>
+                  <a:srgbClr val="D97706"/>
+                </a:solidFill>
+                <a:latin typeface="Arial" pitchFamily="34" charset="0"/>
+                <a:ea typeface="Arial" pitchFamily="34" charset="-122"/>
+                <a:cs typeface="Arial" pitchFamily="34" charset="-120"/>
+              </a:rPr>
+              <a:t>manquantes</a:t>
+            </a:r>
+            <a:br>
+              <a:rPr lang="en-US" sz="1100" dirty="0"/>
+            </a:br>
             <a:r>
               <a:rPr lang="en-US" sz="1100" dirty="0">
                 <a:solidFill>
@@ -7249,7 +7129,7 @@
                 <a:ea typeface="Arial" pitchFamily="34" charset="-122"/>
                 <a:cs typeface="Arial" pitchFamily="34" charset="-120"/>
               </a:rPr>
-              <a:t> (notes ou assiduite non scrapees pour certaines classes)</a:t>
+              <a:t>(notes ou assiduite non scrapees pour certaines classes)</a:t>
             </a:r>
             <a:endParaRPr lang="en-US" sz="1100" dirty="0"/>
           </a:p>
@@ -7292,6 +7172,7 @@
         <a:solidFill>
           <a:srgbClr val="FFFFFF"/>
         </a:solidFill>
+        <a:effectLst/>
       </p:bgPr>
     </p:bg>
     <p:spTree>
@@ -7329,7 +7210,7 @@
           <a:bodyPr wrap="square" lIns="0" tIns="0" rIns="0" bIns="0" rtlCol="0" anchor="ctr"/>
           <a:lstStyle/>
           <a:p>
-            <a:pPr indent="0" marL="0">
+            <a:pPr marL="0" indent="0">
               <a:buNone/>
             </a:pPr>
             <a:r>
@@ -7386,7 +7267,7 @@
           </a:solidFill>
           <a:ln/>
           <a:effectLst>
-            <a:outerShdw sx="100000" sy="100000" kx="0" ky="0" algn="bl" rotWithShape="0" blurRad="76200" dist="25400" dir="8100000">
+            <a:outerShdw blurRad="76200" dist="25400" dir="8100000" algn="bl" rotWithShape="0">
               <a:srgbClr val="000000">
                 <a:alpha val="12000"/>
               </a:srgbClr>
@@ -7435,7 +7316,7 @@
           <a:bodyPr wrap="square" rtlCol="0" anchor="ctr"/>
           <a:lstStyle/>
           <a:p>
-            <a:pPr algn="ctr" indent="0" marL="0">
+            <a:pPr marL="0" indent="0" algn="ctr">
               <a:buNone/>
             </a:pPr>
             <a:r>
@@ -7474,7 +7355,7 @@
           <a:bodyPr wrap="square" rtlCol="0" anchor="ctr"/>
           <a:lstStyle/>
           <a:p>
-            <a:pPr indent="0" marL="0">
+            <a:pPr marL="0" indent="0">
               <a:lnSpc>
                 <a:spcPct val="140000"/>
               </a:lnSpc>
@@ -7494,7 +7375,7 @@
             <a:endParaRPr lang="en-US" sz="1100" dirty="0"/>
           </a:p>
           <a:p>
-            <a:pPr indent="0" marL="0">
+            <a:pPr marL="0" indent="0">
               <a:lnSpc>
                 <a:spcPct val="140000"/>
               </a:lnSpc>
@@ -7514,7 +7395,7 @@
             <a:endParaRPr lang="en-US" sz="1100" dirty="0"/>
           </a:p>
           <a:p>
-            <a:pPr indent="0" marL="0">
+            <a:pPr marL="0" indent="0">
               <a:lnSpc>
                 <a:spcPct val="140000"/>
               </a:lnSpc>
@@ -7534,7 +7415,7 @@
             <a:endParaRPr lang="en-US" sz="1100" dirty="0"/>
           </a:p>
           <a:p>
-            <a:pPr indent="0" marL="0">
+            <a:pPr marL="0" indent="0">
               <a:lnSpc>
                 <a:spcPct val="140000"/>
               </a:lnSpc>
@@ -7554,7 +7435,7 @@
             <a:endParaRPr lang="en-US" sz="1100" dirty="0"/>
           </a:p>
           <a:p>
-            <a:pPr indent="0" marL="0">
+            <a:pPr marL="0" indent="0">
               <a:lnSpc>
                 <a:spcPct val="140000"/>
               </a:lnSpc>
@@ -7594,7 +7475,7 @@
           </a:solidFill>
           <a:ln/>
           <a:effectLst>
-            <a:outerShdw sx="100000" sy="100000" kx="0" ky="0" algn="bl" rotWithShape="0" blurRad="76200" dist="25400" dir="8100000">
+            <a:outerShdw blurRad="76200" dist="25400" dir="8100000" algn="bl" rotWithShape="0">
               <a:srgbClr val="000000">
                 <a:alpha val="12000"/>
               </a:srgbClr>
@@ -7643,7 +7524,7 @@
           <a:bodyPr wrap="square" rtlCol="0" anchor="ctr"/>
           <a:lstStyle/>
           <a:p>
-            <a:pPr algn="ctr" indent="0" marL="0">
+            <a:pPr marL="0" indent="0" algn="ctr">
               <a:buNone/>
             </a:pPr>
             <a:r>
@@ -7682,7 +7563,7 @@
           <a:bodyPr wrap="square" rtlCol="0" anchor="ctr"/>
           <a:lstStyle/>
           <a:p>
-            <a:pPr indent="0" marL="0">
+            <a:pPr marL="0" indent="0">
               <a:lnSpc>
                 <a:spcPct val="140000"/>
               </a:lnSpc>
@@ -7702,7 +7583,7 @@
             <a:endParaRPr lang="en-US" sz="1100" dirty="0"/>
           </a:p>
           <a:p>
-            <a:pPr indent="0" marL="0">
+            <a:pPr marL="0" indent="0">
               <a:lnSpc>
                 <a:spcPct val="140000"/>
               </a:lnSpc>
@@ -7722,7 +7603,7 @@
             <a:endParaRPr lang="en-US" sz="1100" dirty="0"/>
           </a:p>
           <a:p>
-            <a:pPr indent="0" marL="0">
+            <a:pPr marL="0" indent="0">
               <a:lnSpc>
                 <a:spcPct val="140000"/>
               </a:lnSpc>
@@ -7742,7 +7623,7 @@
             <a:endParaRPr lang="en-US" sz="1100" dirty="0"/>
           </a:p>
           <a:p>
-            <a:pPr indent="0" marL="0">
+            <a:pPr marL="0" indent="0">
               <a:lnSpc>
                 <a:spcPct val="140000"/>
               </a:lnSpc>
@@ -7762,7 +7643,7 @@
             <a:endParaRPr lang="en-US" sz="1100" dirty="0"/>
           </a:p>
           <a:p>
-            <a:pPr indent="0" marL="0">
+            <a:pPr marL="0" indent="0">
               <a:lnSpc>
                 <a:spcPct val="140000"/>
               </a:lnSpc>
@@ -7802,7 +7683,7 @@
           </a:solidFill>
           <a:ln/>
           <a:effectLst>
-            <a:outerShdw sx="100000" sy="100000" kx="0" ky="0" algn="bl" rotWithShape="0" blurRad="76200" dist="25400" dir="8100000">
+            <a:outerShdw blurRad="76200" dist="25400" dir="8100000" algn="bl" rotWithShape="0">
               <a:srgbClr val="000000">
                 <a:alpha val="12000"/>
               </a:srgbClr>
@@ -7851,7 +7732,7 @@
           <a:bodyPr wrap="square" rtlCol="0" anchor="ctr"/>
           <a:lstStyle/>
           <a:p>
-            <a:pPr algn="ctr" indent="0" marL="0">
+            <a:pPr marL="0" indent="0" algn="ctr">
               <a:buNone/>
             </a:pPr>
             <a:r>
@@ -7890,7 +7771,7 @@
           <a:bodyPr wrap="square" rtlCol="0" anchor="ctr"/>
           <a:lstStyle/>
           <a:p>
-            <a:pPr indent="0" marL="0">
+            <a:pPr marL="0" indent="0">
               <a:lnSpc>
                 <a:spcPct val="140000"/>
               </a:lnSpc>
@@ -7910,7 +7791,7 @@
             <a:endParaRPr lang="en-US" sz="1100" dirty="0"/>
           </a:p>
           <a:p>
-            <a:pPr indent="0" marL="0">
+            <a:pPr marL="0" indent="0">
               <a:lnSpc>
                 <a:spcPct val="140000"/>
               </a:lnSpc>
@@ -7930,7 +7811,7 @@
             <a:endParaRPr lang="en-US" sz="1100" dirty="0"/>
           </a:p>
           <a:p>
-            <a:pPr indent="0" marL="0">
+            <a:pPr marL="0" indent="0">
               <a:lnSpc>
                 <a:spcPct val="140000"/>
               </a:lnSpc>
@@ -7950,7 +7831,7 @@
             <a:endParaRPr lang="en-US" sz="1100" dirty="0"/>
           </a:p>
           <a:p>
-            <a:pPr indent="0" marL="0">
+            <a:pPr marL="0" indent="0">
               <a:lnSpc>
                 <a:spcPct val="140000"/>
               </a:lnSpc>
@@ -7970,7 +7851,7 @@
             <a:endParaRPr lang="en-US" sz="1100" dirty="0"/>
           </a:p>
           <a:p>
-            <a:pPr indent="0" marL="0">
+            <a:pPr marL="0" indent="0">
               <a:lnSpc>
                 <a:spcPct val="140000"/>
               </a:lnSpc>
@@ -8012,7 +7893,7 @@
           <a:bodyPr wrap="square" rtlCol="0" anchor="ctr"/>
           <a:lstStyle/>
           <a:p>
-            <a:pPr indent="0" marL="0">
+            <a:pPr marL="0" indent="0">
               <a:buNone/>
             </a:pPr>
             <a:r>
@@ -8038,8 +7919,8 @@
         </p:nvSpPr>
         <p:spPr>
           <a:xfrm>
-            <a:off x="457200" y="4023360"/>
-            <a:ext cx="8229600" cy="1371600"/>
+            <a:off x="457200" y="4023927"/>
+            <a:ext cx="8229600" cy="1061196"/>
           </a:xfrm>
           <a:prstGeom prst="rect">
             <a:avLst/>
@@ -8152,6 +8033,7 @@
         <a:solidFill>
           <a:srgbClr val="FFFFFF"/>
         </a:solidFill>
+        <a:effectLst/>
       </p:bgPr>
     </p:bg>
     <p:spTree>
@@ -8189,7 +8071,7 @@
           <a:bodyPr wrap="square" lIns="0" tIns="0" rIns="0" bIns="0" rtlCol="0" anchor="ctr"/>
           <a:lstStyle/>
           <a:p>
-            <a:pPr indent="0" marL="0">
+            <a:pPr marL="0" indent="0">
               <a:buNone/>
             </a:pPr>
             <a:r>
@@ -8243,17 +8125,41 @@
         </p:nvGraphicFramePr>
         <p:xfrm>
           <a:off x="457200" y="1005840"/>
-          <a:ext cx="8229600" cy="914400"/>
+          <a:ext cx="7498080" cy="2194560"/>
         </p:xfrm>
         <a:graphic>
           <a:graphicData uri="http://schemas.openxmlformats.org/drawingml/2006/table">
             <a:tbl>
               <a:tblPr/>
               <a:tblGrid>
-                <a:gridCol w="2011680"/>
-                <a:gridCol w="1645920"/>
-                <a:gridCol w="2926080"/>
-                <a:gridCol w="914400"/>
+                <a:gridCol w="2011680">
+                  <a:extLst>
+                    <a:ext uri="{9D8B030D-6E8A-4147-A177-3AD203B41FA5}">
+                      <a16:colId xmlns:a16="http://schemas.microsoft.com/office/drawing/2014/main" val="20000"/>
+                    </a:ext>
+                  </a:extLst>
+                </a:gridCol>
+                <a:gridCol w="1645920">
+                  <a:extLst>
+                    <a:ext uri="{9D8B030D-6E8A-4147-A177-3AD203B41FA5}">
+                      <a16:colId xmlns:a16="http://schemas.microsoft.com/office/drawing/2014/main" val="20001"/>
+                    </a:ext>
+                  </a:extLst>
+                </a:gridCol>
+                <a:gridCol w="2926080">
+                  <a:extLst>
+                    <a:ext uri="{9D8B030D-6E8A-4147-A177-3AD203B41FA5}">
+                      <a16:colId xmlns:a16="http://schemas.microsoft.com/office/drawing/2014/main" val="20002"/>
+                    </a:ext>
+                  </a:extLst>
+                </a:gridCol>
+                <a:gridCol w="914400">
+                  <a:extLst>
+                    <a:ext uri="{9D8B030D-6E8A-4147-A177-3AD203B41FA5}">
+                      <a16:colId xmlns:a16="http://schemas.microsoft.com/office/drawing/2014/main" val="20003"/>
+                    </a:ext>
+                  </a:extLst>
+                </a:gridCol>
               </a:tblGrid>
               <a:tr h="0">
                 <a:tc>
@@ -8261,7 +8167,7 @@
                     <a:bodyPr/>
                     <a:lstStyle/>
                     <a:p>
-                      <a:pPr indent="0" marL="0">
+                      <a:pPr marL="0" indent="0">
                         <a:buNone/>
                       </a:pPr>
                       <a:r>
@@ -8282,7 +8188,7 @@
                       </a:endParaRPr>
                     </a:p>
                   </a:txBody>
-                  <a:tcPr marL="91440" marR="91440" marT="45720" marB="45720">
+                  <a:tcPr>
                     <a:lnL w="6350" cap="flat" cmpd="sng" algn="ctr">
                       <a:solidFill>
                         <a:srgbClr val="E2E8F0"/>
@@ -8329,7 +8235,7 @@
                     <a:bodyPr/>
                     <a:lstStyle/>
                     <a:p>
-                      <a:pPr indent="0" marL="0">
+                      <a:pPr marL="0" indent="0">
                         <a:buNone/>
                       </a:pPr>
                       <a:r>
@@ -8350,7 +8256,7 @@
                       </a:endParaRPr>
                     </a:p>
                   </a:txBody>
-                  <a:tcPr marL="91440" marR="91440" marT="45720" marB="45720">
+                  <a:tcPr>
                     <a:lnL w="6350" cap="flat" cmpd="sng" algn="ctr">
                       <a:solidFill>
                         <a:srgbClr val="E2E8F0"/>
@@ -8397,7 +8303,7 @@
                     <a:bodyPr/>
                     <a:lstStyle/>
                     <a:p>
-                      <a:pPr indent="0" marL="0">
+                      <a:pPr marL="0" indent="0">
                         <a:buNone/>
                       </a:pPr>
                       <a:r>
@@ -8418,7 +8324,7 @@
                       </a:endParaRPr>
                     </a:p>
                   </a:txBody>
-                  <a:tcPr marL="91440" marR="91440" marT="45720" marB="45720">
+                  <a:tcPr>
                     <a:lnL w="6350" cap="flat" cmpd="sng" algn="ctr">
                       <a:solidFill>
                         <a:srgbClr val="E2E8F0"/>
@@ -8465,7 +8371,7 @@
                     <a:bodyPr/>
                     <a:lstStyle/>
                     <a:p>
-                      <a:pPr indent="0" marL="0">
+                      <a:pPr marL="0" indent="0">
                         <a:buNone/>
                       </a:pPr>
                       <a:r>
@@ -8486,7 +8392,7 @@
                       </a:endParaRPr>
                     </a:p>
                   </a:txBody>
-                  <a:tcPr marL="91440" marR="91440" marT="45720" marB="45720">
+                  <a:tcPr>
                     <a:lnL w="6350" cap="flat" cmpd="sng" algn="ctr">
                       <a:solidFill>
                         <a:srgbClr val="E2E8F0"/>
@@ -8528,6 +8434,11 @@
                     </a:solidFill>
                   </a:tcPr>
                 </a:tc>
+                <a:extLst>
+                  <a:ext uri="{0D108BD9-81ED-4DB2-BD59-A6C34878D82A}">
+                    <a16:rowId xmlns:a16="http://schemas.microsoft.com/office/drawing/2014/main" val="10000"/>
+                  </a:ext>
+                </a:extLst>
               </a:tr>
               <a:tr h="0">
                 <a:tc>
@@ -8535,7 +8446,7 @@
                     <a:bodyPr/>
                     <a:lstStyle/>
                     <a:p>
-                      <a:pPr indent="0" marL="0">
+                      <a:pPr marL="0" indent="0">
                         <a:buNone/>
                       </a:pPr>
                       <a:r>
@@ -8556,7 +8467,7 @@
                       </a:endParaRPr>
                     </a:p>
                   </a:txBody>
-                  <a:tcPr marL="91440" marR="91440" marT="45720" marB="45720">
+                  <a:tcPr>
                     <a:lnL w="6350" cap="flat" cmpd="sng" algn="ctr">
                       <a:solidFill>
                         <a:srgbClr val="E2E8F0"/>
@@ -8603,7 +8514,7 @@
                     <a:bodyPr/>
                     <a:lstStyle/>
                     <a:p>
-                      <a:pPr indent="0" marL="0">
+                      <a:pPr marL="0" indent="0">
                         <a:buNone/>
                       </a:pPr>
                       <a:r>
@@ -8624,7 +8535,7 @@
                       </a:endParaRPr>
                     </a:p>
                   </a:txBody>
-                  <a:tcPr marL="91440" marR="91440" marT="45720" marB="45720">
+                  <a:tcPr>
                     <a:lnL w="6350" cap="flat" cmpd="sng" algn="ctr">
                       <a:solidFill>
                         <a:srgbClr val="E2E8F0"/>
@@ -8671,7 +8582,7 @@
                     <a:bodyPr/>
                     <a:lstStyle/>
                     <a:p>
-                      <a:pPr indent="0" marL="0">
+                      <a:pPr marL="0" indent="0">
                         <a:buNone/>
                       </a:pPr>
                       <a:r>
@@ -8692,7 +8603,7 @@
                       </a:endParaRPr>
                     </a:p>
                   </a:txBody>
-                  <a:tcPr marL="91440" marR="91440" marT="45720" marB="45720">
+                  <a:tcPr>
                     <a:lnL w="6350" cap="flat" cmpd="sng" algn="ctr">
                       <a:solidFill>
                         <a:srgbClr val="E2E8F0"/>
@@ -8739,7 +8650,7 @@
                     <a:bodyPr/>
                     <a:lstStyle/>
                     <a:p>
-                      <a:pPr indent="0" marL="0">
+                      <a:pPr marL="0" indent="0">
                         <a:buNone/>
                       </a:pPr>
                       <a:r>
@@ -8760,7 +8671,7 @@
                       </a:endParaRPr>
                     </a:p>
                   </a:txBody>
-                  <a:tcPr marL="91440" marR="91440" marT="45720" marB="45720">
+                  <a:tcPr>
                     <a:lnL w="6350" cap="flat" cmpd="sng" algn="ctr">
                       <a:solidFill>
                         <a:srgbClr val="E2E8F0"/>
@@ -8802,6 +8713,11 @@
                     </a:solidFill>
                   </a:tcPr>
                 </a:tc>
+                <a:extLst>
+                  <a:ext uri="{0D108BD9-81ED-4DB2-BD59-A6C34878D82A}">
+                    <a16:rowId xmlns:a16="http://schemas.microsoft.com/office/drawing/2014/main" val="10001"/>
+                  </a:ext>
+                </a:extLst>
               </a:tr>
               <a:tr h="0">
                 <a:tc>
@@ -8809,7 +8725,7 @@
                     <a:bodyPr/>
                     <a:lstStyle/>
                     <a:p>
-                      <a:pPr indent="0" marL="0">
+                      <a:pPr marL="0" indent="0">
                         <a:buNone/>
                       </a:pPr>
                       <a:r>
@@ -8830,7 +8746,7 @@
                       </a:endParaRPr>
                     </a:p>
                   </a:txBody>
-                  <a:tcPr marL="91440" marR="91440" marT="45720" marB="45720">
+                  <a:tcPr>
                     <a:lnL w="6350" cap="flat" cmpd="sng" algn="ctr">
                       <a:solidFill>
                         <a:srgbClr val="E2E8F0"/>
@@ -8877,7 +8793,7 @@
                     <a:bodyPr/>
                     <a:lstStyle/>
                     <a:p>
-                      <a:pPr indent="0" marL="0">
+                      <a:pPr marL="0" indent="0">
                         <a:buNone/>
                       </a:pPr>
                       <a:r>
@@ -8898,7 +8814,7 @@
                       </a:endParaRPr>
                     </a:p>
                   </a:txBody>
-                  <a:tcPr marL="91440" marR="91440" marT="45720" marB="45720">
+                  <a:tcPr>
                     <a:lnL w="6350" cap="flat" cmpd="sng" algn="ctr">
                       <a:solidFill>
                         <a:srgbClr val="E2E8F0"/>
@@ -8945,7 +8861,7 @@
                     <a:bodyPr/>
                     <a:lstStyle/>
                     <a:p>
-                      <a:pPr indent="0" marL="0">
+                      <a:pPr marL="0" indent="0">
                         <a:buNone/>
                       </a:pPr>
                       <a:r>
@@ -8966,7 +8882,7 @@
                       </a:endParaRPr>
                     </a:p>
                   </a:txBody>
-                  <a:tcPr marL="91440" marR="91440" marT="45720" marB="45720">
+                  <a:tcPr>
                     <a:lnL w="6350" cap="flat" cmpd="sng" algn="ctr">
                       <a:solidFill>
                         <a:srgbClr val="E2E8F0"/>
@@ -9013,7 +8929,7 @@
                     <a:bodyPr/>
                     <a:lstStyle/>
                     <a:p>
-                      <a:pPr indent="0" marL="0">
+                      <a:pPr marL="0" indent="0">
                         <a:buNone/>
                       </a:pPr>
                       <a:r>
@@ -9034,7 +8950,7 @@
                       </a:endParaRPr>
                     </a:p>
                   </a:txBody>
-                  <a:tcPr marL="91440" marR="91440" marT="45720" marB="45720">
+                  <a:tcPr>
                     <a:lnL w="6350" cap="flat" cmpd="sng" algn="ctr">
                       <a:solidFill>
                         <a:srgbClr val="E2E8F0"/>
@@ -9076,6 +8992,11 @@
                     </a:solidFill>
                   </a:tcPr>
                 </a:tc>
+                <a:extLst>
+                  <a:ext uri="{0D108BD9-81ED-4DB2-BD59-A6C34878D82A}">
+                    <a16:rowId xmlns:a16="http://schemas.microsoft.com/office/drawing/2014/main" val="10002"/>
+                  </a:ext>
+                </a:extLst>
               </a:tr>
               <a:tr h="0">
                 <a:tc>
@@ -9083,7 +9004,7 @@
                     <a:bodyPr/>
                     <a:lstStyle/>
                     <a:p>
-                      <a:pPr indent="0" marL="0">
+                      <a:pPr marL="0" indent="0">
                         <a:buNone/>
                       </a:pPr>
                       <a:r>
@@ -9104,7 +9025,7 @@
                       </a:endParaRPr>
                     </a:p>
                   </a:txBody>
-                  <a:tcPr marL="91440" marR="91440" marT="45720" marB="45720">
+                  <a:tcPr>
                     <a:lnL w="6350" cap="flat" cmpd="sng" algn="ctr">
                       <a:solidFill>
                         <a:srgbClr val="E2E8F0"/>
@@ -9151,7 +9072,7 @@
                     <a:bodyPr/>
                     <a:lstStyle/>
                     <a:p>
-                      <a:pPr indent="0" marL="0">
+                      <a:pPr marL="0" indent="0">
                         <a:buNone/>
                       </a:pPr>
                       <a:r>
@@ -9172,7 +9093,7 @@
                       </a:endParaRPr>
                     </a:p>
                   </a:txBody>
-                  <a:tcPr marL="91440" marR="91440" marT="45720" marB="45720">
+                  <a:tcPr>
                     <a:lnL w="6350" cap="flat" cmpd="sng" algn="ctr">
                       <a:solidFill>
                         <a:srgbClr val="E2E8F0"/>
@@ -9219,7 +9140,7 @@
                     <a:bodyPr/>
                     <a:lstStyle/>
                     <a:p>
-                      <a:pPr indent="0" marL="0">
+                      <a:pPr marL="0" indent="0">
                         <a:buNone/>
                       </a:pPr>
                       <a:r>
@@ -9240,7 +9161,7 @@
                       </a:endParaRPr>
                     </a:p>
                   </a:txBody>
-                  <a:tcPr marL="91440" marR="91440" marT="45720" marB="45720">
+                  <a:tcPr>
                     <a:lnL w="6350" cap="flat" cmpd="sng" algn="ctr">
                       <a:solidFill>
                         <a:srgbClr val="E2E8F0"/>
@@ -9287,7 +9208,7 @@
                     <a:bodyPr/>
                     <a:lstStyle/>
                     <a:p>
-                      <a:pPr indent="0" marL="0">
+                      <a:pPr marL="0" indent="0">
                         <a:buNone/>
                       </a:pPr>
                       <a:r>
@@ -9308,7 +9229,7 @@
                       </a:endParaRPr>
                     </a:p>
                   </a:txBody>
-                  <a:tcPr marL="91440" marR="91440" marT="45720" marB="45720">
+                  <a:tcPr>
                     <a:lnL w="6350" cap="flat" cmpd="sng" algn="ctr">
                       <a:solidFill>
                         <a:srgbClr val="E2E8F0"/>
@@ -9350,6 +9271,11 @@
                     </a:solidFill>
                   </a:tcPr>
                 </a:tc>
+                <a:extLst>
+                  <a:ext uri="{0D108BD9-81ED-4DB2-BD59-A6C34878D82A}">
+                    <a16:rowId xmlns:a16="http://schemas.microsoft.com/office/drawing/2014/main" val="10003"/>
+                  </a:ext>
+                </a:extLst>
               </a:tr>
               <a:tr h="0">
                 <a:tc>
@@ -9357,7 +9283,7 @@
                     <a:bodyPr/>
                     <a:lstStyle/>
                     <a:p>
-                      <a:pPr indent="0" marL="0">
+                      <a:pPr marL="0" indent="0">
                         <a:buNone/>
                       </a:pPr>
                       <a:r>
@@ -9378,7 +9304,7 @@
                       </a:endParaRPr>
                     </a:p>
                   </a:txBody>
-                  <a:tcPr marL="91440" marR="91440" marT="45720" marB="45720">
+                  <a:tcPr>
                     <a:lnL w="6350" cap="flat" cmpd="sng" algn="ctr">
                       <a:solidFill>
                         <a:srgbClr val="E2E8F0"/>
@@ -9425,7 +9351,7 @@
                     <a:bodyPr/>
                     <a:lstStyle/>
                     <a:p>
-                      <a:pPr indent="0" marL="0">
+                      <a:pPr marL="0" indent="0">
                         <a:buNone/>
                       </a:pPr>
                       <a:r>
@@ -9446,7 +9372,7 @@
                       </a:endParaRPr>
                     </a:p>
                   </a:txBody>
-                  <a:tcPr marL="91440" marR="91440" marT="45720" marB="45720">
+                  <a:tcPr>
                     <a:lnL w="6350" cap="flat" cmpd="sng" algn="ctr">
                       <a:solidFill>
                         <a:srgbClr val="E2E8F0"/>
@@ -9493,7 +9419,7 @@
                     <a:bodyPr/>
                     <a:lstStyle/>
                     <a:p>
-                      <a:pPr indent="0" marL="0">
+                      <a:pPr marL="0" indent="0">
                         <a:buNone/>
                       </a:pPr>
                       <a:r>
@@ -9514,7 +9440,7 @@
                       </a:endParaRPr>
                     </a:p>
                   </a:txBody>
-                  <a:tcPr marL="91440" marR="91440" marT="45720" marB="45720">
+                  <a:tcPr>
                     <a:lnL w="6350" cap="flat" cmpd="sng" algn="ctr">
                       <a:solidFill>
                         <a:srgbClr val="E2E8F0"/>
@@ -9561,7 +9487,7 @@
                     <a:bodyPr/>
                     <a:lstStyle/>
                     <a:p>
-                      <a:pPr indent="0" marL="0">
+                      <a:pPr marL="0" indent="0">
                         <a:buNone/>
                       </a:pPr>
                       <a:r>
@@ -9582,7 +9508,7 @@
                       </a:endParaRPr>
                     </a:p>
                   </a:txBody>
-                  <a:tcPr marL="91440" marR="91440" marT="45720" marB="45720">
+                  <a:tcPr>
                     <a:lnL w="6350" cap="flat" cmpd="sng" algn="ctr">
                       <a:solidFill>
                         <a:srgbClr val="E2E8F0"/>
@@ -9624,6 +9550,11 @@
                     </a:solidFill>
                   </a:tcPr>
                 </a:tc>
+                <a:extLst>
+                  <a:ext uri="{0D108BD9-81ED-4DB2-BD59-A6C34878D82A}">
+                    <a16:rowId xmlns:a16="http://schemas.microsoft.com/office/drawing/2014/main" val="10004"/>
+                  </a:ext>
+                </a:extLst>
               </a:tr>
               <a:tr h="0">
                 <a:tc>
@@ -9631,7 +9562,7 @@
                     <a:bodyPr/>
                     <a:lstStyle/>
                     <a:p>
-                      <a:pPr indent="0" marL="0">
+                      <a:pPr marL="0" indent="0">
                         <a:buNone/>
                       </a:pPr>
                       <a:r>
@@ -9652,7 +9583,7 @@
                       </a:endParaRPr>
                     </a:p>
                   </a:txBody>
-                  <a:tcPr marL="91440" marR="91440" marT="45720" marB="45720">
+                  <a:tcPr>
                     <a:lnL w="6350" cap="flat" cmpd="sng" algn="ctr">
                       <a:solidFill>
                         <a:srgbClr val="E2E8F0"/>
@@ -9699,7 +9630,7 @@
                     <a:bodyPr/>
                     <a:lstStyle/>
                     <a:p>
-                      <a:pPr indent="0" marL="0">
+                      <a:pPr marL="0" indent="0">
                         <a:buNone/>
                       </a:pPr>
                       <a:r>
@@ -9720,7 +9651,7 @@
                       </a:endParaRPr>
                     </a:p>
                   </a:txBody>
-                  <a:tcPr marL="91440" marR="91440" marT="45720" marB="45720">
+                  <a:tcPr>
                     <a:lnL w="6350" cap="flat" cmpd="sng" algn="ctr">
                       <a:solidFill>
                         <a:srgbClr val="E2E8F0"/>
@@ -9767,7 +9698,7 @@
                     <a:bodyPr/>
                     <a:lstStyle/>
                     <a:p>
-                      <a:pPr indent="0" marL="0">
+                      <a:pPr marL="0" indent="0">
                         <a:buNone/>
                       </a:pPr>
                       <a:r>
@@ -9788,7 +9719,7 @@
                       </a:endParaRPr>
                     </a:p>
                   </a:txBody>
-                  <a:tcPr marL="91440" marR="91440" marT="45720" marB="45720">
+                  <a:tcPr>
                     <a:lnL w="6350" cap="flat" cmpd="sng" algn="ctr">
                       <a:solidFill>
                         <a:srgbClr val="E2E8F0"/>
@@ -9835,7 +9766,7 @@
                     <a:bodyPr/>
                     <a:lstStyle/>
                     <a:p>
-                      <a:pPr indent="0" marL="0">
+                      <a:pPr marL="0" indent="0">
                         <a:buNone/>
                       </a:pPr>
                       <a:r>
@@ -9856,7 +9787,7 @@
                       </a:endParaRPr>
                     </a:p>
                   </a:txBody>
-                  <a:tcPr marL="91440" marR="91440" marT="45720" marB="45720">
+                  <a:tcPr>
                     <a:lnL w="6350" cap="flat" cmpd="sng" algn="ctr">
                       <a:solidFill>
                         <a:srgbClr val="E2E8F0"/>
@@ -9898,6 +9829,11 @@
                     </a:solidFill>
                   </a:tcPr>
                 </a:tc>
+                <a:extLst>
+                  <a:ext uri="{0D108BD9-81ED-4DB2-BD59-A6C34878D82A}">
+                    <a16:rowId xmlns:a16="http://schemas.microsoft.com/office/drawing/2014/main" val="10005"/>
+                  </a:ext>
+                </a:extLst>
               </a:tr>
               <a:tr h="0">
                 <a:tc>
@@ -9905,7 +9841,7 @@
                     <a:bodyPr/>
                     <a:lstStyle/>
                     <a:p>
-                      <a:pPr indent="0" marL="0">
+                      <a:pPr marL="0" indent="0">
                         <a:buNone/>
                       </a:pPr>
                       <a:r>
@@ -9926,7 +9862,7 @@
                       </a:endParaRPr>
                     </a:p>
                   </a:txBody>
-                  <a:tcPr marL="91440" marR="91440" marT="45720" marB="45720">
+                  <a:tcPr>
                     <a:lnL w="6350" cap="flat" cmpd="sng" algn="ctr">
                       <a:solidFill>
                         <a:srgbClr val="E2E8F0"/>
@@ -9973,7 +9909,7 @@
                     <a:bodyPr/>
                     <a:lstStyle/>
                     <a:p>
-                      <a:pPr indent="0" marL="0">
+                      <a:pPr marL="0" indent="0">
                         <a:buNone/>
                       </a:pPr>
                       <a:r>
@@ -9994,7 +9930,7 @@
                       </a:endParaRPr>
                     </a:p>
                   </a:txBody>
-                  <a:tcPr marL="91440" marR="91440" marT="45720" marB="45720">
+                  <a:tcPr>
                     <a:lnL w="6350" cap="flat" cmpd="sng" algn="ctr">
                       <a:solidFill>
                         <a:srgbClr val="E2E8F0"/>
@@ -10041,7 +9977,7 @@
                     <a:bodyPr/>
                     <a:lstStyle/>
                     <a:p>
-                      <a:pPr indent="0" marL="0">
+                      <a:pPr marL="0" indent="0">
                         <a:buNone/>
                       </a:pPr>
                       <a:r>
@@ -10062,7 +9998,7 @@
                       </a:endParaRPr>
                     </a:p>
                   </a:txBody>
-                  <a:tcPr marL="91440" marR="91440" marT="45720" marB="45720">
+                  <a:tcPr>
                     <a:lnL w="6350" cap="flat" cmpd="sng" algn="ctr">
                       <a:solidFill>
                         <a:srgbClr val="E2E8F0"/>
@@ -10109,7 +10045,7 @@
                     <a:bodyPr/>
                     <a:lstStyle/>
                     <a:p>
-                      <a:pPr indent="0" marL="0">
+                      <a:pPr marL="0" indent="0">
                         <a:buNone/>
                       </a:pPr>
                       <a:r>
@@ -10130,7 +10066,7 @@
                       </a:endParaRPr>
                     </a:p>
                   </a:txBody>
-                  <a:tcPr marL="91440" marR="91440" marT="45720" marB="45720">
+                  <a:tcPr>
                     <a:lnL w="6350" cap="flat" cmpd="sng" algn="ctr">
                       <a:solidFill>
                         <a:srgbClr val="E2E8F0"/>
@@ -10172,6 +10108,11 @@
                     </a:solidFill>
                   </a:tcPr>
                 </a:tc>
+                <a:extLst>
+                  <a:ext uri="{0D108BD9-81ED-4DB2-BD59-A6C34878D82A}">
+                    <a16:rowId xmlns:a16="http://schemas.microsoft.com/office/drawing/2014/main" val="10006"/>
+                  </a:ext>
+                </a:extLst>
               </a:tr>
               <a:tr h="0">
                 <a:tc>
@@ -10179,7 +10120,7 @@
                     <a:bodyPr/>
                     <a:lstStyle/>
                     <a:p>
-                      <a:pPr indent="0" marL="0">
+                      <a:pPr marL="0" indent="0">
                         <a:buNone/>
                       </a:pPr>
                       <a:r>
@@ -10200,7 +10141,7 @@
                       </a:endParaRPr>
                     </a:p>
                   </a:txBody>
-                  <a:tcPr marL="91440" marR="91440" marT="45720" marB="45720">
+                  <a:tcPr>
                     <a:lnL w="6350" cap="flat" cmpd="sng" algn="ctr">
                       <a:solidFill>
                         <a:srgbClr val="E2E8F0"/>
@@ -10247,7 +10188,7 @@
                     <a:bodyPr/>
                     <a:lstStyle/>
                     <a:p>
-                      <a:pPr indent="0" marL="0">
+                      <a:pPr marL="0" indent="0">
                         <a:buNone/>
                       </a:pPr>
                       <a:r>
@@ -10268,7 +10209,7 @@
                       </a:endParaRPr>
                     </a:p>
                   </a:txBody>
-                  <a:tcPr marL="91440" marR="91440" marT="45720" marB="45720">
+                  <a:tcPr>
                     <a:lnL w="6350" cap="flat" cmpd="sng" algn="ctr">
                       <a:solidFill>
                         <a:srgbClr val="E2E8F0"/>
@@ -10315,7 +10256,7 @@
                     <a:bodyPr/>
                     <a:lstStyle/>
                     <a:p>
-                      <a:pPr indent="0" marL="0">
+                      <a:pPr marL="0" indent="0">
                         <a:buNone/>
                       </a:pPr>
                       <a:r>
@@ -10336,7 +10277,7 @@
                       </a:endParaRPr>
                     </a:p>
                   </a:txBody>
-                  <a:tcPr marL="91440" marR="91440" marT="45720" marB="45720">
+                  <a:tcPr>
                     <a:lnL w="6350" cap="flat" cmpd="sng" algn="ctr">
                       <a:solidFill>
                         <a:srgbClr val="E2E8F0"/>
@@ -10383,7 +10324,7 @@
                     <a:bodyPr/>
                     <a:lstStyle/>
                     <a:p>
-                      <a:pPr indent="0" marL="0">
+                      <a:pPr marL="0" indent="0">
                         <a:buNone/>
                       </a:pPr>
                       <a:r>
@@ -10404,7 +10345,7 @@
                       </a:endParaRPr>
                     </a:p>
                   </a:txBody>
-                  <a:tcPr marL="91440" marR="91440" marT="45720" marB="45720">
+                  <a:tcPr>
                     <a:lnL w="6350" cap="flat" cmpd="sng" algn="ctr">
                       <a:solidFill>
                         <a:srgbClr val="E2E8F0"/>
@@ -10446,6 +10387,11 @@
                     </a:solidFill>
                   </a:tcPr>
                 </a:tc>
+                <a:extLst>
+                  <a:ext uri="{0D108BD9-81ED-4DB2-BD59-A6C34878D82A}">
+                    <a16:rowId xmlns:a16="http://schemas.microsoft.com/office/drawing/2014/main" val="10007"/>
+                  </a:ext>
+                </a:extLst>
               </a:tr>
               <a:tr h="0">
                 <a:tc>
@@ -10453,7 +10399,7 @@
                     <a:bodyPr/>
                     <a:lstStyle/>
                     <a:p>
-                      <a:pPr indent="0" marL="0">
+                      <a:pPr marL="0" indent="0">
                         <a:buNone/>
                       </a:pPr>
                       <a:r>
@@ -10474,7 +10420,7 @@
                       </a:endParaRPr>
                     </a:p>
                   </a:txBody>
-                  <a:tcPr marL="91440" marR="91440" marT="45720" marB="45720">
+                  <a:tcPr>
                     <a:lnL w="6350" cap="flat" cmpd="sng" algn="ctr">
                       <a:solidFill>
                         <a:srgbClr val="E2E8F0"/>
@@ -10521,7 +10467,7 @@
                     <a:bodyPr/>
                     <a:lstStyle/>
                     <a:p>
-                      <a:pPr indent="0" marL="0">
+                      <a:pPr marL="0" indent="0">
                         <a:buNone/>
                       </a:pPr>
                       <a:r>
@@ -10542,7 +10488,7 @@
                       </a:endParaRPr>
                     </a:p>
                   </a:txBody>
-                  <a:tcPr marL="91440" marR="91440" marT="45720" marB="45720">
+                  <a:tcPr>
                     <a:lnL w="6350" cap="flat" cmpd="sng" algn="ctr">
                       <a:solidFill>
                         <a:srgbClr val="E2E8F0"/>
@@ -10589,7 +10535,7 @@
                     <a:bodyPr/>
                     <a:lstStyle/>
                     <a:p>
-                      <a:pPr indent="0" marL="0">
+                      <a:pPr marL="0" indent="0">
                         <a:buNone/>
                       </a:pPr>
                       <a:r>
@@ -10610,7 +10556,7 @@
                       </a:endParaRPr>
                     </a:p>
                   </a:txBody>
-                  <a:tcPr marL="91440" marR="91440" marT="45720" marB="45720">
+                  <a:tcPr>
                     <a:lnL w="6350" cap="flat" cmpd="sng" algn="ctr">
                       <a:solidFill>
                         <a:srgbClr val="E2E8F0"/>
@@ -10657,7 +10603,7 @@
                     <a:bodyPr/>
                     <a:lstStyle/>
                     <a:p>
-                      <a:pPr indent="0" marL="0">
+                      <a:pPr marL="0" indent="0">
                         <a:buNone/>
                       </a:pPr>
                       <a:r>
@@ -10678,7 +10624,7 @@
                       </a:endParaRPr>
                     </a:p>
                   </a:txBody>
-                  <a:tcPr marL="91440" marR="91440" marT="45720" marB="45720">
+                  <a:tcPr>
                     <a:lnL w="6350" cap="flat" cmpd="sng" algn="ctr">
                       <a:solidFill>
                         <a:srgbClr val="E2E8F0"/>
@@ -10720,6 +10666,11 @@
                     </a:solidFill>
                   </a:tcPr>
                 </a:tc>
+                <a:extLst>
+                  <a:ext uri="{0D108BD9-81ED-4DB2-BD59-A6C34878D82A}">
+                    <a16:rowId xmlns:a16="http://schemas.microsoft.com/office/drawing/2014/main" val="10008"/>
+                  </a:ext>
+                </a:extLst>
               </a:tr>
             </a:tbl>
           </a:graphicData>
@@ -10741,6 +10692,7 @@
         <a:solidFill>
           <a:srgbClr val="FFFFFF"/>
         </a:solidFill>
+        <a:effectLst/>
       </p:bgPr>
     </p:bg>
     <p:spTree>
@@ -10778,7 +10730,7 @@
           <a:bodyPr wrap="square" lIns="0" tIns="0" rIns="0" bIns="0" rtlCol="0" anchor="ctr"/>
           <a:lstStyle/>
           <a:p>
-            <a:pPr indent="0" marL="0">
+            <a:pPr marL="0" indent="0">
               <a:buNone/>
             </a:pPr>
             <a:r>
@@ -10857,7 +10809,7 @@
           <a:bodyPr wrap="square" rtlCol="0" anchor="ctr"/>
           <a:lstStyle/>
           <a:p>
-            <a:pPr algn="ctr" indent="0" marL="0">
+            <a:pPr marL="0" indent="0" algn="ctr">
               <a:buNone/>
             </a:pPr>
             <a:r>
@@ -10896,7 +10848,7 @@
           <a:bodyPr wrap="square" rtlCol="0" anchor="ctr"/>
           <a:lstStyle/>
           <a:p>
-            <a:pPr indent="0" marL="0">
+            <a:pPr marL="0" indent="0">
               <a:buNone/>
             </a:pPr>
             <a:r>
@@ -10935,7 +10887,7 @@
           <a:bodyPr wrap="square" rtlCol="0" anchor="ctr"/>
           <a:lstStyle/>
           <a:p>
-            <a:pPr indent="0" marL="0">
+            <a:pPr marL="0" indent="0">
               <a:buNone/>
             </a:pPr>
             <a:r>
@@ -10974,7 +10926,7 @@
           <a:bodyPr wrap="square" rtlCol="0" anchor="ctr"/>
           <a:lstStyle/>
           <a:p>
-            <a:pPr indent="0" marL="0">
+            <a:pPr marL="0" indent="0">
               <a:buNone/>
             </a:pPr>
             <a:r>
@@ -11053,7 +11005,7 @@
           <a:bodyPr wrap="square" rtlCol="0" anchor="ctr"/>
           <a:lstStyle/>
           <a:p>
-            <a:pPr algn="ctr" indent="0" marL="0">
+            <a:pPr marL="0" indent="0" algn="ctr">
               <a:buNone/>
             </a:pPr>
             <a:r>
@@ -11092,7 +11044,7 @@
           <a:bodyPr wrap="square" rtlCol="0" anchor="ctr"/>
           <a:lstStyle/>
           <a:p>
-            <a:pPr indent="0" marL="0">
+            <a:pPr marL="0" indent="0">
               <a:buNone/>
             </a:pPr>
             <a:r>
@@ -11131,7 +11083,7 @@
           <a:bodyPr wrap="square" rtlCol="0" anchor="ctr"/>
           <a:lstStyle/>
           <a:p>
-            <a:pPr indent="0" marL="0">
+            <a:pPr marL="0" indent="0">
               <a:buNone/>
             </a:pPr>
             <a:r>
@@ -11170,7 +11122,7 @@
           <a:bodyPr wrap="square" rtlCol="0" anchor="ctr"/>
           <a:lstStyle/>
           <a:p>
-            <a:pPr indent="0" marL="0">
+            <a:pPr marL="0" indent="0">
               <a:buNone/>
             </a:pPr>
             <a:r>
@@ -11249,7 +11201,7 @@
           <a:bodyPr wrap="square" rtlCol="0" anchor="ctr"/>
           <a:lstStyle/>
           <a:p>
-            <a:pPr algn="ctr" indent="0" marL="0">
+            <a:pPr marL="0" indent="0" algn="ctr">
               <a:buNone/>
             </a:pPr>
             <a:r>
@@ -11288,7 +11240,7 @@
           <a:bodyPr wrap="square" rtlCol="0" anchor="ctr"/>
           <a:lstStyle/>
           <a:p>
-            <a:pPr indent="0" marL="0">
+            <a:pPr marL="0" indent="0">
               <a:buNone/>
             </a:pPr>
             <a:r>
@@ -11327,7 +11279,7 @@
           <a:bodyPr wrap="square" rtlCol="0" anchor="ctr"/>
           <a:lstStyle/>
           <a:p>
-            <a:pPr indent="0" marL="0">
+            <a:pPr marL="0" indent="0">
               <a:buNone/>
             </a:pPr>
             <a:r>
@@ -11366,7 +11318,7 @@
           <a:bodyPr wrap="square" rtlCol="0" anchor="ctr"/>
           <a:lstStyle/>
           <a:p>
-            <a:pPr indent="0" marL="0">
+            <a:pPr marL="0" indent="0">
               <a:buNone/>
             </a:pPr>
             <a:r>
@@ -11445,7 +11397,7 @@
           <a:bodyPr wrap="square" rtlCol="0" anchor="ctr"/>
           <a:lstStyle/>
           <a:p>
-            <a:pPr algn="ctr" indent="0" marL="0">
+            <a:pPr marL="0" indent="0" algn="ctr">
               <a:buNone/>
             </a:pPr>
             <a:r>
@@ -11484,7 +11436,7 @@
           <a:bodyPr wrap="square" rtlCol="0" anchor="ctr"/>
           <a:lstStyle/>
           <a:p>
-            <a:pPr indent="0" marL="0">
+            <a:pPr marL="0" indent="0">
               <a:buNone/>
             </a:pPr>
             <a:r>
@@ -11523,7 +11475,7 @@
           <a:bodyPr wrap="square" rtlCol="0" anchor="ctr"/>
           <a:lstStyle/>
           <a:p>
-            <a:pPr indent="0" marL="0">
+            <a:pPr marL="0" indent="0">
               <a:buNone/>
             </a:pPr>
             <a:r>
@@ -11562,7 +11514,7 @@
           <a:bodyPr wrap="square" rtlCol="0" anchor="ctr"/>
           <a:lstStyle/>
           <a:p>
-            <a:pPr indent="0" marL="0">
+            <a:pPr marL="0" indent="0">
               <a:buNone/>
             </a:pPr>
             <a:r>
@@ -11641,7 +11593,7 @@
           <a:bodyPr wrap="square" rtlCol="0" anchor="ctr"/>
           <a:lstStyle/>
           <a:p>
-            <a:pPr algn="ctr" indent="0" marL="0">
+            <a:pPr marL="0" indent="0" algn="ctr">
               <a:buNone/>
             </a:pPr>
             <a:r>
@@ -11680,7 +11632,7 @@
           <a:bodyPr wrap="square" rtlCol="0" anchor="ctr"/>
           <a:lstStyle/>
           <a:p>
-            <a:pPr indent="0" marL="0">
+            <a:pPr marL="0" indent="0">
               <a:buNone/>
             </a:pPr>
             <a:r>
@@ -11719,7 +11671,7 @@
           <a:bodyPr wrap="square" rtlCol="0" anchor="ctr"/>
           <a:lstStyle/>
           <a:p>
-            <a:pPr indent="0" marL="0">
+            <a:pPr marL="0" indent="0">
               <a:buNone/>
             </a:pPr>
             <a:r>
@@ -11758,7 +11710,7 @@
           <a:bodyPr wrap="square" rtlCol="0" anchor="ctr"/>
           <a:lstStyle/>
           <a:p>
-            <a:pPr indent="0" marL="0">
+            <a:pPr marL="0" indent="0">
               <a:buNone/>
             </a:pPr>
             <a:r>
@@ -11792,6 +11744,7 @@
         <a:solidFill>
           <a:srgbClr val="FFFFFF"/>
         </a:solidFill>
+        <a:effectLst/>
       </p:bgPr>
     </p:bg>
     <p:spTree>
@@ -11829,7 +11782,7 @@
           <a:bodyPr wrap="square" lIns="0" tIns="0" rIns="0" bIns="0" rtlCol="0" anchor="ctr"/>
           <a:lstStyle/>
           <a:p>
-            <a:pPr indent="0" marL="0">
+            <a:pPr marL="0" indent="0">
               <a:buNone/>
             </a:pPr>
             <a:r>
@@ -11886,7 +11839,7 @@
           </a:solidFill>
           <a:ln/>
           <a:effectLst>
-            <a:outerShdw sx="100000" sy="100000" kx="0" ky="0" algn="bl" rotWithShape="0" blurRad="76200" dist="25400" dir="8100000">
+            <a:outerShdw blurRad="76200" dist="25400" dir="8100000" algn="bl" rotWithShape="0">
               <a:srgbClr val="000000">
                 <a:alpha val="12000"/>
               </a:srgbClr>
@@ -11935,7 +11888,7 @@
           <a:bodyPr wrap="square" rtlCol="0" anchor="ctr"/>
           <a:lstStyle/>
           <a:p>
-            <a:pPr indent="0" marL="0">
+            <a:pPr marL="0" indent="0">
               <a:buNone/>
             </a:pPr>
             <a:r>
@@ -11974,7 +11927,7 @@
           <a:bodyPr wrap="square" rtlCol="0" anchor="ctr"/>
           <a:lstStyle/>
           <a:p>
-            <a:pPr indent="0" marL="0">
+            <a:pPr marL="0" indent="0">
               <a:lnSpc>
                 <a:spcPct val="150000"/>
               </a:lnSpc>
@@ -11994,7 +11947,7 @@
             <a:endParaRPr lang="en-US" sz="1100" dirty="0"/>
           </a:p>
           <a:p>
-            <a:pPr indent="0" marL="0">
+            <a:pPr marL="0" indent="0">
               <a:lnSpc>
                 <a:spcPct val="150000"/>
               </a:lnSpc>
@@ -12014,7 +11967,7 @@
             <a:endParaRPr lang="en-US" sz="1100" dirty="0"/>
           </a:p>
           <a:p>
-            <a:pPr indent="0" marL="0">
+            <a:pPr marL="0" indent="0">
               <a:lnSpc>
                 <a:spcPct val="150000"/>
               </a:lnSpc>
@@ -12034,7 +11987,7 @@
             <a:endParaRPr lang="en-US" sz="1100" dirty="0"/>
           </a:p>
           <a:p>
-            <a:pPr indent="0" marL="0">
+            <a:pPr marL="0" indent="0">
               <a:lnSpc>
                 <a:spcPct val="150000"/>
               </a:lnSpc>
@@ -12074,7 +12027,7 @@
           </a:solidFill>
           <a:ln/>
           <a:effectLst>
-            <a:outerShdw sx="100000" sy="100000" kx="0" ky="0" algn="bl" rotWithShape="0" blurRad="76200" dist="25400" dir="8100000">
+            <a:outerShdw blurRad="76200" dist="25400" dir="8100000" algn="bl" rotWithShape="0">
               <a:srgbClr val="000000">
                 <a:alpha val="12000"/>
               </a:srgbClr>
@@ -12123,7 +12076,7 @@
           <a:bodyPr wrap="square" rtlCol="0" anchor="ctr"/>
           <a:lstStyle/>
           <a:p>
-            <a:pPr indent="0" marL="0">
+            <a:pPr marL="0" indent="0">
               <a:buNone/>
             </a:pPr>
             <a:r>
@@ -12162,7 +12115,7 @@
           <a:bodyPr wrap="square" rtlCol="0" anchor="ctr"/>
           <a:lstStyle/>
           <a:p>
-            <a:pPr indent="0" marL="0">
+            <a:pPr marL="0" indent="0">
               <a:lnSpc>
                 <a:spcPct val="150000"/>
               </a:lnSpc>
@@ -12182,7 +12135,7 @@
             <a:endParaRPr lang="en-US" sz="1100" dirty="0"/>
           </a:p>
           <a:p>
-            <a:pPr indent="0" marL="0">
+            <a:pPr marL="0" indent="0">
               <a:lnSpc>
                 <a:spcPct val="150000"/>
               </a:lnSpc>
@@ -12202,7 +12155,7 @@
             <a:endParaRPr lang="en-US" sz="1100" dirty="0"/>
           </a:p>
           <a:p>
-            <a:pPr indent="0" marL="0">
+            <a:pPr marL="0" indent="0">
               <a:lnSpc>
                 <a:spcPct val="150000"/>
               </a:lnSpc>
@@ -12222,7 +12175,7 @@
             <a:endParaRPr lang="en-US" sz="1100" dirty="0"/>
           </a:p>
           <a:p>
-            <a:pPr indent="0" marL="0">
+            <a:pPr marL="0" indent="0">
               <a:lnSpc>
                 <a:spcPct val="150000"/>
               </a:lnSpc>
@@ -12262,7 +12215,7 @@
           </a:solidFill>
           <a:ln/>
           <a:effectLst>
-            <a:outerShdw sx="100000" sy="100000" kx="0" ky="0" algn="bl" rotWithShape="0" blurRad="76200" dist="25400" dir="8100000">
+            <a:outerShdw blurRad="76200" dist="25400" dir="8100000" algn="bl" rotWithShape="0">
               <a:srgbClr val="000000">
                 <a:alpha val="12000"/>
               </a:srgbClr>
@@ -12311,7 +12264,7 @@
           <a:bodyPr wrap="square" rtlCol="0" anchor="ctr"/>
           <a:lstStyle/>
           <a:p>
-            <a:pPr indent="0" marL="0">
+            <a:pPr marL="0" indent="0">
               <a:buNone/>
             </a:pPr>
             <a:r>
@@ -12350,7 +12303,7 @@
           <a:bodyPr wrap="square" rtlCol="0" anchor="ctr"/>
           <a:lstStyle/>
           <a:p>
-            <a:pPr indent="0" marL="0">
+            <a:pPr marL="0" indent="0">
               <a:lnSpc>
                 <a:spcPct val="150000"/>
               </a:lnSpc>
@@ -12370,7 +12323,7 @@
             <a:endParaRPr lang="en-US" sz="1100" dirty="0"/>
           </a:p>
           <a:p>
-            <a:pPr indent="0" marL="0">
+            <a:pPr marL="0" indent="0">
               <a:lnSpc>
                 <a:spcPct val="150000"/>
               </a:lnSpc>
@@ -12390,7 +12343,7 @@
             <a:endParaRPr lang="en-US" sz="1100" dirty="0"/>
           </a:p>
           <a:p>
-            <a:pPr indent="0" marL="0">
+            <a:pPr marL="0" indent="0">
               <a:lnSpc>
                 <a:spcPct val="150000"/>
               </a:lnSpc>
@@ -12410,7 +12363,7 @@
             <a:endParaRPr lang="en-US" sz="1100" dirty="0"/>
           </a:p>
           <a:p>
-            <a:pPr indent="0" marL="0">
+            <a:pPr marL="0" indent="0">
               <a:lnSpc>
                 <a:spcPct val="150000"/>
               </a:lnSpc>
@@ -12472,7 +12425,7 @@
           <a:bodyPr wrap="square" rtlCol="0" anchor="ctr"/>
           <a:lstStyle/>
           <a:p>
-            <a:pPr indent="0" marL="0">
+            <a:pPr marL="0" indent="0">
               <a:buNone/>
             </a:pPr>
             <a:r>
@@ -12506,6 +12459,7 @@
         <a:solidFill>
           <a:srgbClr val="1A1A2E"/>
         </a:solidFill>
+        <a:effectLst/>
       </p:bgPr>
     </p:bg>
     <p:spTree>
@@ -12543,11 +12497,11 @@
           <a:bodyPr wrap="square" rtlCol="0" anchor="ctr"/>
           <a:lstStyle/>
           <a:p>
-            <a:pPr indent="0" marL="0">
+            <a:pPr marL="0" indent="0">
               <a:buNone/>
             </a:pPr>
             <a:r>
-              <a:rPr lang="en-US" sz="3600" b="1" spc="400" kern="0" dirty="0">
+              <a:rPr lang="en-US" sz="3600" b="1" kern="0" spc="400" dirty="0">
                 <a:solidFill>
                   <a:srgbClr val="FFFFFF"/>
                 </a:solidFill>
@@ -12602,7 +12556,7 @@
           <a:bodyPr wrap="square" rtlCol="0" anchor="ctr"/>
           <a:lstStyle/>
           <a:p>
-            <a:pPr indent="0" marL="0">
+            <a:pPr marL="0" indent="0">
               <a:spcAft>
                 <a:spcPts val="1000"/>
               </a:spcAft>
@@ -12619,12 +12573,6 @@
               </a:rPr>
               <a:t>1. </a:t>
             </a:r>
-            <a:pPr indent="0" marL="0">
-              <a:spcAft>
-                <a:spcPts val="1000"/>
-              </a:spcAft>
-              <a:buNone/>
-            </a:pPr>
             <a:r>
               <a:rPr lang="en-US" sz="1600" dirty="0">
                 <a:solidFill>
@@ -12639,7 +12587,7 @@
             <a:endParaRPr lang="en-US" sz="1600" dirty="0"/>
           </a:p>
           <a:p>
-            <a:pPr indent="0" marL="0">
+            <a:pPr marL="0" indent="0">
               <a:spcAft>
                 <a:spcPts val="1000"/>
               </a:spcAft>
@@ -12656,12 +12604,6 @@
               </a:rPr>
               <a:t>2. </a:t>
             </a:r>
-            <a:pPr indent="0" marL="0">
-              <a:spcAft>
-                <a:spcPts val="1000"/>
-              </a:spcAft>
-              <a:buNone/>
-            </a:pPr>
             <a:r>
               <a:rPr lang="en-US" sz="1600" dirty="0">
                 <a:solidFill>
@@ -12676,7 +12618,7 @@
             <a:endParaRPr lang="en-US" sz="1600" dirty="0"/>
           </a:p>
           <a:p>
-            <a:pPr indent="0" marL="0">
+            <a:pPr marL="0" indent="0">
               <a:spcAft>
                 <a:spcPts val="1000"/>
               </a:spcAft>
@@ -12693,12 +12635,6 @@
               </a:rPr>
               <a:t>3. </a:t>
             </a:r>
-            <a:pPr indent="0" marL="0">
-              <a:spcAft>
-                <a:spcPts val="1000"/>
-              </a:spcAft>
-              <a:buNone/>
-            </a:pPr>
             <a:r>
               <a:rPr lang="en-US" sz="1600" dirty="0">
                 <a:solidFill>
@@ -12713,7 +12649,7 @@
             <a:endParaRPr lang="en-US" sz="1600" dirty="0"/>
           </a:p>
           <a:p>
-            <a:pPr indent="0" marL="0">
+            <a:pPr marL="0" indent="0">
               <a:spcAft>
                 <a:spcPts val="1000"/>
               </a:spcAft>
@@ -12730,12 +12666,6 @@
               </a:rPr>
               <a:t>4. </a:t>
             </a:r>
-            <a:pPr indent="0" marL="0">
-              <a:spcAft>
-                <a:spcPts val="1000"/>
-              </a:spcAft>
-              <a:buNone/>
-            </a:pPr>
             <a:r>
               <a:rPr lang="en-US" sz="1600" dirty="0">
                 <a:solidFill>
@@ -12750,7 +12680,7 @@
             <a:endParaRPr lang="en-US" sz="1600" dirty="0"/>
           </a:p>
           <a:p>
-            <a:pPr indent="0" marL="0">
+            <a:pPr marL="0" indent="0">
               <a:spcAft>
                 <a:spcPts val="1000"/>
               </a:spcAft>
@@ -12767,12 +12697,6 @@
               </a:rPr>
               <a:t>5. </a:t>
             </a:r>
-            <a:pPr indent="0" marL="0">
-              <a:spcAft>
-                <a:spcPts val="1000"/>
-              </a:spcAft>
-              <a:buNone/>
-            </a:pPr>
             <a:r>
               <a:rPr lang="en-US" sz="1600" dirty="0">
                 <a:solidFill>
@@ -12809,7 +12733,7 @@
           <a:bodyPr wrap="square" rtlCol="0" anchor="ctr"/>
           <a:lstStyle/>
           <a:p>
-            <a:pPr indent="0" marL="0">
+            <a:pPr marL="0" indent="0">
               <a:buNone/>
             </a:pPr>
             <a:r>
@@ -13128,4 +13052,319 @@
     </a:ext>
   </a:extLst>
 </a:theme>
+</file>
+
+<file path=ppt/theme/theme2.xml><?xml version="1.0" encoding="utf-8"?>
+<a:theme xmlns:a="http://schemas.openxmlformats.org/drawingml/2006/main" name="Thème Office">
+  <a:themeElements>
+    <a:clrScheme name="Office">
+      <a:dk1>
+        <a:sysClr val="windowText" lastClr="000000"/>
+      </a:dk1>
+      <a:lt1>
+        <a:sysClr val="window" lastClr="FFFFFF"/>
+      </a:lt1>
+      <a:dk2>
+        <a:srgbClr val="0E2841"/>
+      </a:dk2>
+      <a:lt2>
+        <a:srgbClr val="E8E8E8"/>
+      </a:lt2>
+      <a:accent1>
+        <a:srgbClr val="156082"/>
+      </a:accent1>
+      <a:accent2>
+        <a:srgbClr val="E97132"/>
+      </a:accent2>
+      <a:accent3>
+        <a:srgbClr val="196B24"/>
+      </a:accent3>
+      <a:accent4>
+        <a:srgbClr val="0F9ED5"/>
+      </a:accent4>
+      <a:accent5>
+        <a:srgbClr val="A02B93"/>
+      </a:accent5>
+      <a:accent6>
+        <a:srgbClr val="4EA72E"/>
+      </a:accent6>
+      <a:hlink>
+        <a:srgbClr val="467886"/>
+      </a:hlink>
+      <a:folHlink>
+        <a:srgbClr val="96607D"/>
+      </a:folHlink>
+    </a:clrScheme>
+    <a:fontScheme name="Office">
+      <a:majorFont>
+        <a:latin typeface="Aptos Display" panose="02110004020202020204"/>
+        <a:ea typeface=""/>
+        <a:cs typeface=""/>
+        <a:font script="Jpan" typeface="游ゴシック Light"/>
+        <a:font script="Hang" typeface="맑은 고딕"/>
+        <a:font script="Hans" typeface="等线 Light"/>
+        <a:font script="Hant" typeface="新細明體"/>
+        <a:font script="Arab" typeface="Times New Roman"/>
+        <a:font script="Hebr" typeface="Times New Roman"/>
+        <a:font script="Thai" typeface="Angsana New"/>
+        <a:font script="Ethi" typeface="Nyala"/>
+        <a:font script="Beng" typeface="Vrinda"/>
+        <a:font script="Gujr" typeface="Shruti"/>
+        <a:font script="Khmr" typeface="MoolBoran"/>
+        <a:font script="Knda" typeface="Tunga"/>
+        <a:font script="Guru" typeface="Raavi"/>
+        <a:font script="Cans" typeface="Euphemia"/>
+        <a:font script="Cher" typeface="Plantagenet Cherokee"/>
+        <a:font script="Yiii" typeface="Microsoft Yi Baiti"/>
+        <a:font script="Tibt" typeface="Microsoft Himalaya"/>
+        <a:font script="Thaa" typeface="MV Boli"/>
+        <a:font script="Deva" typeface="Mangal"/>
+        <a:font script="Telu" typeface="Gautami"/>
+        <a:font script="Taml" typeface="Latha"/>
+        <a:font script="Syrc" typeface="Estrangelo Edessa"/>
+        <a:font script="Orya" typeface="Kalinga"/>
+        <a:font script="Mlym" typeface="Kartika"/>
+        <a:font script="Laoo" typeface="DokChampa"/>
+        <a:font script="Sinh" typeface="Iskoola Pota"/>
+        <a:font script="Mong" typeface="Mongolian Baiti"/>
+        <a:font script="Viet" typeface="Times New Roman"/>
+        <a:font script="Uigh" typeface="Microsoft Uighur"/>
+        <a:font script="Geor" typeface="Sylfaen"/>
+        <a:font script="Armn" typeface="Arial"/>
+        <a:font script="Bugi" typeface="Leelawadee UI"/>
+        <a:font script="Bopo" typeface="Microsoft JhengHei"/>
+        <a:font script="Java" typeface="Javanese Text"/>
+        <a:font script="Lisu" typeface="Segoe UI"/>
+        <a:font script="Mymr" typeface="Myanmar Text"/>
+        <a:font script="Nkoo" typeface="Ebrima"/>
+        <a:font script="Olck" typeface="Nirmala UI"/>
+        <a:font script="Osma" typeface="Ebrima"/>
+        <a:font script="Phag" typeface="Phagspa"/>
+        <a:font script="Syrn" typeface="Estrangelo Edessa"/>
+        <a:font script="Syrj" typeface="Estrangelo Edessa"/>
+        <a:font script="Syre" typeface="Estrangelo Edessa"/>
+        <a:font script="Sora" typeface="Nirmala UI"/>
+        <a:font script="Tale" typeface="Microsoft Tai Le"/>
+        <a:font script="Talu" typeface="Microsoft New Tai Lue"/>
+        <a:font script="Tfng" typeface="Ebrima"/>
+      </a:majorFont>
+      <a:minorFont>
+        <a:latin typeface="Aptos" panose="02110004020202020204"/>
+        <a:ea typeface=""/>
+        <a:cs typeface=""/>
+        <a:font script="Jpan" typeface="游ゴシック"/>
+        <a:font script="Hang" typeface="맑은 고딕"/>
+        <a:font script="Hans" typeface="等线"/>
+        <a:font script="Hant" typeface="新細明體"/>
+        <a:font script="Arab" typeface="Arial"/>
+        <a:font script="Hebr" typeface="Arial"/>
+        <a:font script="Thai" typeface="Cordia New"/>
+        <a:font script="Ethi" typeface="Nyala"/>
+        <a:font script="Beng" typeface="Vrinda"/>
+        <a:font script="Gujr" typeface="Shruti"/>
+        <a:font script="Khmr" typeface="DaunPenh"/>
+        <a:font script="Knda" typeface="Tunga"/>
+        <a:font script="Guru" typeface="Raavi"/>
+        <a:font script="Cans" typeface="Euphemia"/>
+        <a:font script="Cher" typeface="Plantagenet Cherokee"/>
+        <a:font script="Yiii" typeface="Microsoft Yi Baiti"/>
+        <a:font script="Tibt" typeface="Microsoft Himalaya"/>
+        <a:font script="Thaa" typeface="MV Boli"/>
+        <a:font script="Deva" typeface="Mangal"/>
+        <a:font script="Telu" typeface="Gautami"/>
+        <a:font script="Taml" typeface="Latha"/>
+        <a:font script="Syrc" typeface="Estrangelo Edessa"/>
+        <a:font script="Orya" typeface="Kalinga"/>
+        <a:font script="Mlym" typeface="Kartika"/>
+        <a:font script="Laoo" typeface="DokChampa"/>
+        <a:font script="Sinh" typeface="Iskoola Pota"/>
+        <a:font script="Mong" typeface="Mongolian Baiti"/>
+        <a:font script="Viet" typeface="Arial"/>
+        <a:font script="Uigh" typeface="Microsoft Uighur"/>
+        <a:font script="Geor" typeface="Sylfaen"/>
+        <a:font script="Armn" typeface="Arial"/>
+        <a:font script="Bugi" typeface="Leelawadee UI"/>
+        <a:font script="Bopo" typeface="Microsoft JhengHei"/>
+        <a:font script="Java" typeface="Javanese Text"/>
+        <a:font script="Lisu" typeface="Segoe UI"/>
+        <a:font script="Mymr" typeface="Myanmar Text"/>
+        <a:font script="Nkoo" typeface="Ebrima"/>
+        <a:font script="Olck" typeface="Nirmala UI"/>
+        <a:font script="Osma" typeface="Ebrima"/>
+        <a:font script="Phag" typeface="Phagspa"/>
+        <a:font script="Syrn" typeface="Estrangelo Edessa"/>
+        <a:font script="Syrj" typeface="Estrangelo Edessa"/>
+        <a:font script="Syre" typeface="Estrangelo Edessa"/>
+        <a:font script="Sora" typeface="Nirmala UI"/>
+        <a:font script="Tale" typeface="Microsoft Tai Le"/>
+        <a:font script="Talu" typeface="Microsoft New Tai Lue"/>
+        <a:font script="Tfng" typeface="Ebrima"/>
+      </a:minorFont>
+    </a:fontScheme>
+    <a:fmtScheme name="Office">
+      <a:fillStyleLst>
+        <a:solidFill>
+          <a:schemeClr val="phClr"/>
+        </a:solidFill>
+        <a:gradFill rotWithShape="1">
+          <a:gsLst>
+            <a:gs pos="0">
+              <a:schemeClr val="phClr">
+                <a:lumMod val="110000"/>
+                <a:satMod val="105000"/>
+                <a:tint val="67000"/>
+              </a:schemeClr>
+            </a:gs>
+            <a:gs pos="50000">
+              <a:schemeClr val="phClr">
+                <a:lumMod val="105000"/>
+                <a:satMod val="103000"/>
+                <a:tint val="73000"/>
+              </a:schemeClr>
+            </a:gs>
+            <a:gs pos="100000">
+              <a:schemeClr val="phClr">
+                <a:lumMod val="105000"/>
+                <a:satMod val="109000"/>
+                <a:tint val="81000"/>
+              </a:schemeClr>
+            </a:gs>
+          </a:gsLst>
+          <a:lin ang="5400000" scaled="0"/>
+        </a:gradFill>
+        <a:gradFill rotWithShape="1">
+          <a:gsLst>
+            <a:gs pos="0">
+              <a:schemeClr val="phClr">
+                <a:satMod val="103000"/>
+                <a:lumMod val="102000"/>
+                <a:tint val="94000"/>
+              </a:schemeClr>
+            </a:gs>
+            <a:gs pos="50000">
+              <a:schemeClr val="phClr">
+                <a:satMod val="110000"/>
+                <a:lumMod val="100000"/>
+                <a:shade val="100000"/>
+              </a:schemeClr>
+            </a:gs>
+            <a:gs pos="100000">
+              <a:schemeClr val="phClr">
+                <a:lumMod val="99000"/>
+                <a:satMod val="120000"/>
+                <a:shade val="78000"/>
+              </a:schemeClr>
+            </a:gs>
+          </a:gsLst>
+          <a:lin ang="5400000" scaled="0"/>
+        </a:gradFill>
+      </a:fillStyleLst>
+      <a:lnStyleLst>
+        <a:ln w="12700" cap="flat" cmpd="sng" algn="ctr">
+          <a:solidFill>
+            <a:schemeClr val="phClr"/>
+          </a:solidFill>
+          <a:prstDash val="solid"/>
+          <a:miter lim="800000"/>
+        </a:ln>
+        <a:ln w="19050" cap="flat" cmpd="sng" algn="ctr">
+          <a:solidFill>
+            <a:schemeClr val="phClr"/>
+          </a:solidFill>
+          <a:prstDash val="solid"/>
+          <a:miter lim="800000"/>
+        </a:ln>
+        <a:ln w="25400" cap="flat" cmpd="sng" algn="ctr">
+          <a:solidFill>
+            <a:schemeClr val="phClr"/>
+          </a:solidFill>
+          <a:prstDash val="solid"/>
+          <a:miter lim="800000"/>
+        </a:ln>
+      </a:lnStyleLst>
+      <a:effectStyleLst>
+        <a:effectStyle>
+          <a:effectLst/>
+        </a:effectStyle>
+        <a:effectStyle>
+          <a:effectLst/>
+        </a:effectStyle>
+        <a:effectStyle>
+          <a:effectLst>
+            <a:outerShdw blurRad="57150" dist="19050" dir="5400000" algn="ctr" rotWithShape="0">
+              <a:srgbClr val="000000">
+                <a:alpha val="63000"/>
+              </a:srgbClr>
+            </a:outerShdw>
+          </a:effectLst>
+        </a:effectStyle>
+      </a:effectStyleLst>
+      <a:bgFillStyleLst>
+        <a:solidFill>
+          <a:schemeClr val="phClr"/>
+        </a:solidFill>
+        <a:solidFill>
+          <a:schemeClr val="phClr">
+            <a:tint val="95000"/>
+            <a:satMod val="170000"/>
+          </a:schemeClr>
+        </a:solidFill>
+        <a:gradFill rotWithShape="1">
+          <a:gsLst>
+            <a:gs pos="0">
+              <a:schemeClr val="phClr">
+                <a:tint val="93000"/>
+                <a:satMod val="150000"/>
+                <a:shade val="98000"/>
+                <a:lumMod val="102000"/>
+              </a:schemeClr>
+            </a:gs>
+            <a:gs pos="50000">
+              <a:schemeClr val="phClr">
+                <a:tint val="98000"/>
+                <a:satMod val="130000"/>
+                <a:shade val="90000"/>
+                <a:lumMod val="103000"/>
+              </a:schemeClr>
+            </a:gs>
+            <a:gs pos="100000">
+              <a:schemeClr val="phClr">
+                <a:shade val="63000"/>
+                <a:satMod val="120000"/>
+              </a:schemeClr>
+            </a:gs>
+          </a:gsLst>
+          <a:lin ang="5400000" scaled="0"/>
+        </a:gradFill>
+      </a:bgFillStyleLst>
+    </a:fmtScheme>
+  </a:themeElements>
+  <a:objectDefaults>
+    <a:lnDef>
+      <a:spPr/>
+      <a:bodyPr/>
+      <a:lstStyle/>
+      <a:style>
+        <a:lnRef idx="2">
+          <a:schemeClr val="accent1"/>
+        </a:lnRef>
+        <a:fillRef idx="0">
+          <a:schemeClr val="accent1"/>
+        </a:fillRef>
+        <a:effectRef idx="1">
+          <a:schemeClr val="accent1"/>
+        </a:effectRef>
+        <a:fontRef idx="minor">
+          <a:schemeClr val="tx1"/>
+        </a:fontRef>
+      </a:style>
+    </a:lnDef>
+  </a:objectDefaults>
+  <a:extraClrSchemeLst/>
+  <a:extLst>
+    <a:ext uri="{05A4C25C-085E-4340-85A3-A5531E510DB2}">
+      <thm15:themeFamily xmlns:thm15="http://schemas.microsoft.com/office/thememl/2012/main" name="Office Theme" id="{2E142A2C-CD16-42D6-873A-C26D2A0506FA}" vid="{1BDDFF52-6CD6-40A5-AB3C-68EB2F1E4D0A}"/>
+    </a:ext>
+  </a:extLst>
+</a:theme>
 </file>
</xml_diff>